<commit_message>
Add reproducible hackathon evidence, directional video flow, uncertainty and pilot defense
</commit_message>
<xml_diff>
--- a/DEFENSE.pptx
+++ b/DEFENSE.pptx
@@ -2,20 +2,20 @@
 <file path=ppt/presentation.xml><?xml version="1.0" encoding="utf-8"?>
 <p:presentation xmlns:p="http://schemas.openxmlformats.org/presentationml/2006/main">
   <p:sldMasterIdLst>
-    <p:sldMasterId xmlns:r="http://schemas.openxmlformats.org/officeDocument/2006/relationships" id="2147483648" r:id="Rc5e2f5f73e99475b"/>
+    <p:sldMasterId xmlns:r="http://schemas.openxmlformats.org/officeDocument/2006/relationships" id="2147483648" r:id="Rceb3f216b75e4071"/>
   </p:sldMasterIdLst>
   <p:notesMasterIdLst>
-    <p:notesMasterId xmlns:r="http://schemas.openxmlformats.org/officeDocument/2006/relationships" r:id="R218f31298e644093"/>
+    <p:notesMasterId xmlns:r="http://schemas.openxmlformats.org/officeDocument/2006/relationships" r:id="R5247ca5f60074056"/>
   </p:notesMasterIdLst>
   <p:sldIdLst>
-    <p:sldId xmlns:r="http://schemas.openxmlformats.org/officeDocument/2006/relationships" id="256" r:id="R6d62e0fe4d9d4181"/>
-    <p:sldId xmlns:r="http://schemas.openxmlformats.org/officeDocument/2006/relationships" id="257" r:id="R94fb3f325a164e7a"/>
-    <p:sldId xmlns:r="http://schemas.openxmlformats.org/officeDocument/2006/relationships" id="258" r:id="R40e09d8afced4943"/>
-    <p:sldId xmlns:r="http://schemas.openxmlformats.org/officeDocument/2006/relationships" id="259" r:id="Rbaf1832a3bc84f1d"/>
-    <p:sldId xmlns:r="http://schemas.openxmlformats.org/officeDocument/2006/relationships" id="260" r:id="R1e1e6f8bab284740"/>
-    <p:sldId xmlns:r="http://schemas.openxmlformats.org/officeDocument/2006/relationships" id="261" r:id="Rfa2119d19eff499f"/>
-    <p:sldId xmlns:r="http://schemas.openxmlformats.org/officeDocument/2006/relationships" id="262" r:id="R2a45142f98f34343"/>
-    <p:sldId xmlns:r="http://schemas.openxmlformats.org/officeDocument/2006/relationships" id="263" r:id="R0f64e723f5814366"/>
+    <p:sldId xmlns:r="http://schemas.openxmlformats.org/officeDocument/2006/relationships" id="256" r:id="Ra47e6090b4a1482f"/>
+    <p:sldId xmlns:r="http://schemas.openxmlformats.org/officeDocument/2006/relationships" id="257" r:id="Rd25e7d2e37124608"/>
+    <p:sldId xmlns:r="http://schemas.openxmlformats.org/officeDocument/2006/relationships" id="258" r:id="R2b12358212ee4d9b"/>
+    <p:sldId xmlns:r="http://schemas.openxmlformats.org/officeDocument/2006/relationships" id="259" r:id="Ra655391b8b8a419b"/>
+    <p:sldId xmlns:r="http://schemas.openxmlformats.org/officeDocument/2006/relationships" id="260" r:id="Rf7d253ceaf8347b4"/>
+    <p:sldId xmlns:r="http://schemas.openxmlformats.org/officeDocument/2006/relationships" id="261" r:id="R4fd29910e296402c"/>
+    <p:sldId xmlns:r="http://schemas.openxmlformats.org/officeDocument/2006/relationships" id="262" r:id="Ra445d129b8ea4eaa"/>
+    <p:sldId xmlns:r="http://schemas.openxmlformats.org/officeDocument/2006/relationships" id="263" r:id="R9a92acb14eda4e16"/>
   </p:sldIdLst>
   <p:sldSz cx="12192000" cy="6858000"/>
   <p:notesSz cx="6858000" cy="9144000"/>
@@ -449,7 +449,7 @@
           <a:lstStyle xmlns:a="http://schemas.openxmlformats.org/drawingml/2006/main"/>
           <a:p xmlns:a="http://schemas.openxmlformats.org/drawingml/2006/main">
             <a:r>
-              <a:t>Источники: пользовательская концепция OQIM и условия финала. Код: https://github.com/baytoooo/parivision-traffic (AGPL-3.0), https://github.com/tensorflow/tfjs-models/tree/master/coco-ssd (Apache-2.0). Числа симуляции: benchmark.json, seed 42. Финансовые показатели являются гипотезами.</a:t>
+              <a:t>Режим Startup. Источник требований: правила финала, предоставленные пользователем. Публичный прототип: https://baytoooo.github.io/oqim-ai/ . Полный исходный код: https://github.com/baytoooo/oqim-ai .</a:t>
             </a:r>
           </a:p>
         </p:txBody>
@@ -519,7 +519,7 @@
           <a:lstStyle xmlns:a="http://schemas.openxmlformats.org/drawingml/2006/main"/>
           <a:p xmlns:a="http://schemas.openxmlformats.org/drawingml/2006/main">
             <a:r>
-              <a:t>Источники: пользовательская концепция OQIM и условия финала. Код: https://github.com/baytoooo/parivision-traffic (AGPL-3.0), https://github.com/tensorflow/tfjs-models/tree/master/coco-ssd (Apache-2.0). Числа симуляции: benchmark.json, seed 42. Финансовые показатели являются гипотезами.</a:t>
+              <a:t>Это гипотеза о покупателе и проблеме, не результат интервью. Предлагаемый пилот: PILOT_PLAN.md. Не представлять транспортного оператора или автодилера как существующего клиента.</a:t>
             </a:r>
           </a:p>
         </p:txBody>
@@ -589,7 +589,7 @@
           <a:lstStyle xmlns:a="http://schemas.openxmlformats.org/drawingml/2006/main"/>
           <a:p xmlns:a="http://schemas.openxmlformats.org/drawingml/2006/main">
             <a:r>
-              <a:t>Источники: пользовательская концепция OQIM и условия финала. Код: https://github.com/baytoooo/parivision-traffic (AGPL-3.0), https://github.com/tensorflow/tfjs-models/tree/master/coco-ssd (Apache-2.0). Числа симуляции: benchmark.json, seed 42. Финансовые показатели являются гипотезами.</a:t>
+              <a:t>Скриншот реальной локальной версии1.1, сделанный при браузерной проверке. Страница доказательств пересчитала120сценариев на устройстве. Встроенные видео используются только при отсутствии разрешённого видео жюри. Первую загрузку модели выполнить заранее.</a:t>
             </a:r>
           </a:p>
         </p:txBody>
@@ -659,7 +659,7 @@
           <a:lstStyle xmlns:a="http://schemas.openxmlformats.org/drawingml/2006/main"/>
           <a:p xmlns:a="http://schemas.openxmlformats.org/drawingml/2006/main">
             <a:r>
-              <a:t>Источники: пользовательская концепция OQIM и условия финала. Код: https://github.com/baytoooo/parivision-traffic (AGPL-3.0), https://github.com/tensorflow/tfjs-models/tree/master/coco-ssd (Apache-2.0). Числа симуляции: benchmark.json, seed 42. Финансовые показатели являются гипотезами.</a:t>
+              <a:t>PariVision https://github.com/baytoooo/parivision-traffic , AGPL-3.0, переиспользованные detector.ts/tracker.ts/geometry.ts и pretrainedYOLO26s. OQIM поправляет IoU и добавляет измерение/интеграцию/сеть. Код написан при помощи Codex. Открытые компоненты не выданы за созданные во время финала.</a:t>
             </a:r>
           </a:p>
         </p:txBody>
@@ -729,7 +729,7 @@
           <a:lstStyle xmlns:a="http://schemas.openxmlformats.org/drawingml/2006/main"/>
           <a:p xmlns:a="http://schemas.openxmlformats.org/drawingml/2006/main">
             <a:r>
-              <a:t>Источники: пользовательская концепция OQIM и условия финала. Код: https://github.com/baytoooo/parivision-traffic (AGPL-3.0), https://github.com/tensorflow/tfjs-models/tree/master/coco-ssd (Apache-2.0). Числа симуляции: benchmark.json, seed 42. Финансовые показатели являются гипотезами.</a:t>
+              <a:t>Источник: dist/evidence/network-benchmark.json. npm run benchmark. Фиксированная сетка120сценариев, не подбор лучших. Средние24.55118% и20.05511%. Худшие исходы−28.5587% и−11.5646%. Сужение имеет известное модели расписание. Будущие случайные прибытия скрыты. Нет реального измеренного дорожного эффекта.</a:t>
             </a:r>
           </a:p>
         </p:txBody>
@@ -799,7 +799,7 @@
           <a:lstStyle xmlns:a="http://schemas.openxmlformats.org/drawingml/2006/main"/>
           <a:p xmlns:a="http://schemas.openxmlformats.org/drawingml/2006/main">
             <a:r>
-              <a:t>Источники: пользовательская концепция OQIM и условия финала. Код: https://github.com/baytoooo/parivision-traffic (AGPL-3.0), https://github.com/tensorflow/tfjs-models/tree/master/coco-ssd (Apache-2.0). Числа симуляции: benchmark.json, seed 42. Финансовые показатели являются гипотезами.</a:t>
+              <a:t>Источник измерений: evaluation/motorway-measurement.json и dist/evidence/cv-evaluation.json. Протокол evaluation/PROTOCOL.md заморожен до первого запуска в commitc268abc. Метки: https://github.com/safdar-hussain1/trafficlens/tree/f0eaf0181c1d25e2c05ef95ae7f3cc312e3e1150/data/groundtruth , Safdar Hussain, MIT. Видео: https://commons.wikimedia.org/wiki/File:Motorway_A40_-_on_bridge_above_the_traffic.webm , Kathinka Engels / Sounds of Changes, CC BY3.0. Уменьшено до960px,H.264,беззвука. Малый внешний набор с вероятными метками, не доказательство обобщения. Ночь показывает пропуски, численной оценки точности для ночи нет.</a:t>
             </a:r>
           </a:p>
         </p:txBody>
@@ -869,7 +869,7 @@
           <a:lstStyle xmlns:a="http://schemas.openxmlformats.org/drawingml/2006/main"/>
           <a:p xmlns:a="http://schemas.openxmlformats.org/drawingml/2006/main">
             <a:r>
-              <a:t>Источники: пользовательская концепция OQIM и условия финала. Код: https://github.com/baytoooo/parivision-traffic (AGPL-3.0), https://github.com/tensorflow/tfjs-models/tree/master/coco-ssd (Apache-2.0). Числа симуляции: benchmark.json, seed 42. Финансовые показатели являются гипотезами.</a:t>
+              <a:t>Источник: PILOT_PLAN.md. Гипотезы:1000setup,300subscription,120cost; вклад180. Клиенту для6месяцев окупаемости нужно300+1000/6=466.6667. Финансовых обещаний и подтверждённых продаж нет. Синтетические24.6% не пересчитываются в деньги клиента.</a:t>
             </a:r>
           </a:p>
         </p:txBody>
@@ -939,7 +939,7 @@
           <a:lstStyle xmlns:a="http://schemas.openxmlformats.org/drawingml/2006/main"/>
           <a:p xmlns:a="http://schemas.openxmlformats.org/drawingml/2006/main">
             <a:r>
-              <a:t>Источники: пользовательская концепция OQIM и условия финала. Код: https://github.com/baytoooo/parivision-traffic (AGPL-3.0), https://github.com/tensorflow/tfjs-models/tree/master/coco-ssd (Apache-2.0). Числа симуляции: benchmark.json, seed 42. Финансовые показатели являются гипотезами.</a:t>
+              <a:t>Источник: PILOT_PLAN.md. Критерии являются целями будущего пилота, не достигнутыми результатами. Ночь/дождь проверять отдельно. Минимум20событий на отрезок для относительной ошибки. Результаты не позволяют управлять реальными светофорами без оператора и отдельной интеграции.</a:t>
             </a:r>
           </a:p>
         </p:txBody>
@@ -1037,6 +1037,7 @@
                 <a:spcPts val="0"/>
               </a:spcAft>
               <a:buNone/>
+              <a:defRPr/>
             </a:lvl1pPr>
             <a:lvl2pPr marL="0" indent="0">
               <a:lnSpc>
@@ -1049,6 +1050,7 @@
                 <a:spcPts val="0"/>
               </a:spcAft>
               <a:buNone/>
+              <a:defRPr/>
             </a:lvl2pPr>
             <a:lvl3pPr marL="0" indent="0">
               <a:lnSpc>
@@ -1061,6 +1063,7 @@
                 <a:spcPts val="0"/>
               </a:spcAft>
               <a:buNone/>
+              <a:defRPr/>
             </a:lvl3pPr>
             <a:lvl4pPr marL="0" indent="0">
               <a:lnSpc>
@@ -1073,6 +1076,7 @@
                 <a:spcPts val="0"/>
               </a:spcAft>
               <a:buNone/>
+              <a:defRPr/>
             </a:lvl4pPr>
             <a:lvl5pPr marL="0" indent="0">
               <a:lnSpc>
@@ -1085,6 +1089,7 @@
                 <a:spcPts val="0"/>
               </a:spcAft>
               <a:buNone/>
+              <a:defRPr/>
             </a:lvl5pPr>
             <a:lvl6pPr marL="0" indent="0">
               <a:lnSpc>
@@ -1097,6 +1102,7 @@
                 <a:spcPts val="0"/>
               </a:spcAft>
               <a:buNone/>
+              <a:defRPr/>
             </a:lvl6pPr>
             <a:lvl7pPr marL="0" indent="0">
               <a:lnSpc>
@@ -1109,6 +1115,7 @@
                 <a:spcPts val="0"/>
               </a:spcAft>
               <a:buNone/>
+              <a:defRPr/>
             </a:lvl7pPr>
             <a:lvl8pPr marL="0" indent="0">
               <a:lnSpc>
@@ -1121,6 +1128,7 @@
                 <a:spcPts val="0"/>
               </a:spcAft>
               <a:buNone/>
+              <a:defRPr/>
             </a:lvl8pPr>
             <a:lvl9pPr marL="0" indent="0">
               <a:lnSpc>
@@ -1133,6 +1141,7 @@
                 <a:spcPts val="0"/>
               </a:spcAft>
               <a:buNone/>
+              <a:defRPr/>
             </a:lvl9pPr>
           </a:lstStyle>
           <a:p xmlns:a="http://schemas.openxmlformats.org/drawingml/2006/main"/>
@@ -1194,6 +1203,7 @@
                 <a:spcPts val="0"/>
               </a:spcAft>
               <a:buNone/>
+              <a:defRPr/>
             </a:lvl1pPr>
             <a:lvl2pPr marL="0" indent="0">
               <a:lnSpc>
@@ -1206,6 +1216,7 @@
                 <a:spcPts val="0"/>
               </a:spcAft>
               <a:buNone/>
+              <a:defRPr/>
             </a:lvl2pPr>
             <a:lvl3pPr marL="0" indent="0">
               <a:lnSpc>
@@ -1218,6 +1229,7 @@
                 <a:spcPts val="0"/>
               </a:spcAft>
               <a:buNone/>
+              <a:defRPr/>
             </a:lvl3pPr>
             <a:lvl4pPr marL="0" indent="0">
               <a:lnSpc>
@@ -1230,6 +1242,7 @@
                 <a:spcPts val="0"/>
               </a:spcAft>
               <a:buNone/>
+              <a:defRPr/>
             </a:lvl4pPr>
             <a:lvl5pPr marL="0" indent="0">
               <a:lnSpc>
@@ -1242,6 +1255,7 @@
                 <a:spcPts val="0"/>
               </a:spcAft>
               <a:buNone/>
+              <a:defRPr/>
             </a:lvl5pPr>
             <a:lvl6pPr marL="0" indent="0">
               <a:lnSpc>
@@ -1254,6 +1268,7 @@
                 <a:spcPts val="0"/>
               </a:spcAft>
               <a:buNone/>
+              <a:defRPr/>
             </a:lvl6pPr>
             <a:lvl7pPr marL="0" indent="0">
               <a:lnSpc>
@@ -1266,6 +1281,7 @@
                 <a:spcPts val="0"/>
               </a:spcAft>
               <a:buNone/>
+              <a:defRPr/>
             </a:lvl7pPr>
             <a:lvl8pPr marL="0" indent="0">
               <a:lnSpc>
@@ -1278,6 +1294,7 @@
                 <a:spcPts val="0"/>
               </a:spcAft>
               <a:buNone/>
+              <a:defRPr/>
             </a:lvl8pPr>
             <a:lvl9pPr marL="0" indent="0">
               <a:lnSpc>
@@ -1290,6 +1307,7 @@
                 <a:spcPts val="0"/>
               </a:spcAft>
               <a:buNone/>
+              <a:defRPr/>
             </a:lvl9pPr>
           </a:lstStyle>
           <a:p xmlns:a="http://schemas.openxmlformats.org/drawingml/2006/main"/>
@@ -1368,6 +1386,7 @@
                 <a:spcPts val="0"/>
               </a:spcAft>
               <a:buNone/>
+              <a:defRPr/>
             </a:lvl1pPr>
             <a:lvl2pPr marL="0" indent="0">
               <a:lnSpc>
@@ -1380,6 +1399,7 @@
                 <a:spcPts val="0"/>
               </a:spcAft>
               <a:buNone/>
+              <a:defRPr/>
             </a:lvl2pPr>
             <a:lvl3pPr marL="0" indent="0">
               <a:lnSpc>
@@ -1392,6 +1412,7 @@
                 <a:spcPts val="0"/>
               </a:spcAft>
               <a:buNone/>
+              <a:defRPr/>
             </a:lvl3pPr>
             <a:lvl4pPr marL="0" indent="0">
               <a:lnSpc>
@@ -1404,6 +1425,7 @@
                 <a:spcPts val="0"/>
               </a:spcAft>
               <a:buNone/>
+              <a:defRPr/>
             </a:lvl4pPr>
             <a:lvl5pPr marL="0" indent="0">
               <a:lnSpc>
@@ -1416,6 +1438,7 @@
                 <a:spcPts val="0"/>
               </a:spcAft>
               <a:buNone/>
+              <a:defRPr/>
             </a:lvl5pPr>
             <a:lvl6pPr marL="0" indent="0">
               <a:lnSpc>
@@ -1428,6 +1451,7 @@
                 <a:spcPts val="0"/>
               </a:spcAft>
               <a:buNone/>
+              <a:defRPr/>
             </a:lvl6pPr>
             <a:lvl7pPr marL="0" indent="0">
               <a:lnSpc>
@@ -1440,6 +1464,7 @@
                 <a:spcPts val="0"/>
               </a:spcAft>
               <a:buNone/>
+              <a:defRPr/>
             </a:lvl7pPr>
             <a:lvl8pPr marL="0" indent="0">
               <a:lnSpc>
@@ -1452,6 +1477,7 @@
                 <a:spcPts val="0"/>
               </a:spcAft>
               <a:buNone/>
+              <a:defRPr/>
             </a:lvl8pPr>
             <a:lvl9pPr marL="0" indent="0">
               <a:lnSpc>
@@ -1464,6 +1490,7 @@
                 <a:spcPts val="0"/>
               </a:spcAft>
               <a:buNone/>
+              <a:defRPr/>
             </a:lvl9pPr>
           </a:lstStyle>
           <a:p xmlns:a="http://schemas.openxmlformats.org/drawingml/2006/main"/>
@@ -1542,6 +1569,7 @@
                 <a:spcPts val="0"/>
               </a:spcAft>
               <a:buNone/>
+              <a:defRPr/>
             </a:lvl1pPr>
             <a:lvl2pPr marL="0" indent="0">
               <a:lnSpc>
@@ -1554,6 +1582,7 @@
                 <a:spcPts val="0"/>
               </a:spcAft>
               <a:buNone/>
+              <a:defRPr/>
             </a:lvl2pPr>
             <a:lvl3pPr marL="0" indent="0">
               <a:lnSpc>
@@ -1566,6 +1595,7 @@
                 <a:spcPts val="0"/>
               </a:spcAft>
               <a:buNone/>
+              <a:defRPr/>
             </a:lvl3pPr>
             <a:lvl4pPr marL="0" indent="0">
               <a:lnSpc>
@@ -1578,6 +1608,7 @@
                 <a:spcPts val="0"/>
               </a:spcAft>
               <a:buNone/>
+              <a:defRPr/>
             </a:lvl4pPr>
             <a:lvl5pPr marL="0" indent="0">
               <a:lnSpc>
@@ -1590,6 +1621,7 @@
                 <a:spcPts val="0"/>
               </a:spcAft>
               <a:buNone/>
+              <a:defRPr/>
             </a:lvl5pPr>
             <a:lvl6pPr marL="0" indent="0">
               <a:lnSpc>
@@ -1602,6 +1634,7 @@
                 <a:spcPts val="0"/>
               </a:spcAft>
               <a:buNone/>
+              <a:defRPr/>
             </a:lvl6pPr>
             <a:lvl7pPr marL="0" indent="0">
               <a:lnSpc>
@@ -1614,6 +1647,7 @@
                 <a:spcPts val="0"/>
               </a:spcAft>
               <a:buNone/>
+              <a:defRPr/>
             </a:lvl7pPr>
             <a:lvl8pPr marL="0" indent="0">
               <a:lnSpc>
@@ -1626,6 +1660,7 @@
                 <a:spcPts val="0"/>
               </a:spcAft>
               <a:buNone/>
+              <a:defRPr/>
             </a:lvl8pPr>
             <a:lvl9pPr marL="0" indent="0">
               <a:lnSpc>
@@ -1638,6 +1673,7 @@
                 <a:spcPts val="0"/>
               </a:spcAft>
               <a:buNone/>
+              <a:defRPr/>
             </a:lvl9pPr>
           </a:lstStyle>
           <a:p xmlns:a="http://schemas.openxmlformats.org/drawingml/2006/main"/>
@@ -1699,6 +1735,7 @@
                 <a:spcPts val="1200"/>
               </a:spcAft>
               <a:buChar char="•"/>
+              <a:defRPr/>
             </a:lvl1pPr>
             <a:lvl2pPr marL="533400" indent="-228600">
               <a:lnSpc>
@@ -1711,6 +1748,7 @@
                 <a:spcPts val="1200"/>
               </a:spcAft>
               <a:buChar char="•"/>
+              <a:defRPr/>
             </a:lvl2pPr>
             <a:lvl3pPr marL="838200" indent="-228600">
               <a:lnSpc>
@@ -1723,6 +1761,7 @@
                 <a:spcPts val="1200"/>
               </a:spcAft>
               <a:buChar char="•"/>
+              <a:defRPr/>
             </a:lvl3pPr>
             <a:lvl4pPr marL="1143000" indent="-228600">
               <a:lnSpc>
@@ -1735,6 +1774,7 @@
                 <a:spcPts val="1200"/>
               </a:spcAft>
               <a:buChar char="•"/>
+              <a:defRPr/>
             </a:lvl4pPr>
             <a:lvl5pPr marL="1447800" indent="-228600">
               <a:lnSpc>
@@ -1747,6 +1787,7 @@
                 <a:spcPts val="1200"/>
               </a:spcAft>
               <a:buChar char="•"/>
+              <a:defRPr/>
             </a:lvl5pPr>
             <a:lvl6pPr marL="1752600" indent="-228600">
               <a:lnSpc>
@@ -1759,6 +1800,7 @@
                 <a:spcPts val="1200"/>
               </a:spcAft>
               <a:buChar char="•"/>
+              <a:defRPr/>
             </a:lvl6pPr>
             <a:lvl7pPr marL="2057400" indent="-228600">
               <a:lnSpc>
@@ -1771,6 +1813,7 @@
                 <a:spcPts val="1200"/>
               </a:spcAft>
               <a:buChar char="•"/>
+              <a:defRPr/>
             </a:lvl7pPr>
             <a:lvl8pPr marL="2362200" indent="-228600">
               <a:lnSpc>
@@ -1783,6 +1826,7 @@
                 <a:spcPts val="1200"/>
               </a:spcAft>
               <a:buChar char="•"/>
+              <a:defRPr/>
             </a:lvl8pPr>
             <a:lvl9pPr marL="2667000" indent="-228600">
               <a:lnSpc>
@@ -1795,6 +1839,7 @@
                 <a:spcPts val="1200"/>
               </a:spcAft>
               <a:buChar char="•"/>
+              <a:defRPr/>
             </a:lvl9pPr>
           </a:lstStyle>
           <a:p xmlns:a="http://schemas.openxmlformats.org/drawingml/2006/main"/>
@@ -1873,6 +1918,7 @@
                 <a:spcPts val="0"/>
               </a:spcAft>
               <a:buNone/>
+              <a:defRPr/>
             </a:lvl1pPr>
             <a:lvl2pPr marL="0" indent="0">
               <a:lnSpc>
@@ -1885,6 +1931,7 @@
                 <a:spcPts val="0"/>
               </a:spcAft>
               <a:buNone/>
+              <a:defRPr/>
             </a:lvl2pPr>
             <a:lvl3pPr marL="0" indent="0">
               <a:lnSpc>
@@ -1897,6 +1944,7 @@
                 <a:spcPts val="0"/>
               </a:spcAft>
               <a:buNone/>
+              <a:defRPr/>
             </a:lvl3pPr>
             <a:lvl4pPr marL="0" indent="0">
               <a:lnSpc>
@@ -1909,6 +1957,7 @@
                 <a:spcPts val="0"/>
               </a:spcAft>
               <a:buNone/>
+              <a:defRPr/>
             </a:lvl4pPr>
             <a:lvl5pPr marL="0" indent="0">
               <a:lnSpc>
@@ -1921,6 +1970,7 @@
                 <a:spcPts val="0"/>
               </a:spcAft>
               <a:buNone/>
+              <a:defRPr/>
             </a:lvl5pPr>
             <a:lvl6pPr marL="0" indent="0">
               <a:lnSpc>
@@ -1933,6 +1983,7 @@
                 <a:spcPts val="0"/>
               </a:spcAft>
               <a:buNone/>
+              <a:defRPr/>
             </a:lvl6pPr>
             <a:lvl7pPr marL="0" indent="0">
               <a:lnSpc>
@@ -1945,6 +1996,7 @@
                 <a:spcPts val="0"/>
               </a:spcAft>
               <a:buNone/>
+              <a:defRPr/>
             </a:lvl7pPr>
             <a:lvl8pPr marL="0" indent="0">
               <a:lnSpc>
@@ -1957,6 +2009,7 @@
                 <a:spcPts val="0"/>
               </a:spcAft>
               <a:buNone/>
+              <a:defRPr/>
             </a:lvl8pPr>
             <a:lvl9pPr marL="0" indent="0">
               <a:lnSpc>
@@ -1969,6 +2022,7 @@
                 <a:spcPts val="0"/>
               </a:spcAft>
               <a:buNone/>
+              <a:defRPr/>
             </a:lvl9pPr>
           </a:lstStyle>
           <a:p xmlns:a="http://schemas.openxmlformats.org/drawingml/2006/main"/>
@@ -2030,6 +2084,7 @@
                 <a:spcPts val="1200"/>
               </a:spcAft>
               <a:buChar char="•"/>
+              <a:defRPr/>
             </a:lvl1pPr>
             <a:lvl2pPr marL="533400" indent="-228600">
               <a:lnSpc>
@@ -2042,6 +2097,7 @@
                 <a:spcPts val="1200"/>
               </a:spcAft>
               <a:buChar char="•"/>
+              <a:defRPr/>
             </a:lvl2pPr>
             <a:lvl3pPr marL="838200" indent="-228600">
               <a:lnSpc>
@@ -2054,6 +2110,7 @@
                 <a:spcPts val="1200"/>
               </a:spcAft>
               <a:buChar char="•"/>
+              <a:defRPr/>
             </a:lvl3pPr>
             <a:lvl4pPr marL="1143000" indent="-228600">
               <a:lnSpc>
@@ -2066,6 +2123,7 @@
                 <a:spcPts val="1200"/>
               </a:spcAft>
               <a:buChar char="•"/>
+              <a:defRPr/>
             </a:lvl4pPr>
             <a:lvl5pPr marL="1447800" indent="-228600">
               <a:lnSpc>
@@ -2078,6 +2136,7 @@
                 <a:spcPts val="1200"/>
               </a:spcAft>
               <a:buChar char="•"/>
+              <a:defRPr/>
             </a:lvl5pPr>
             <a:lvl6pPr marL="1752600" indent="-228600">
               <a:lnSpc>
@@ -2090,6 +2149,7 @@
                 <a:spcPts val="1200"/>
               </a:spcAft>
               <a:buChar char="•"/>
+              <a:defRPr/>
             </a:lvl6pPr>
             <a:lvl7pPr marL="2057400" indent="-228600">
               <a:lnSpc>
@@ -2102,6 +2162,7 @@
                 <a:spcPts val="1200"/>
               </a:spcAft>
               <a:buChar char="•"/>
+              <a:defRPr/>
             </a:lvl7pPr>
             <a:lvl8pPr marL="2362200" indent="-228600">
               <a:lnSpc>
@@ -2114,6 +2175,7 @@
                 <a:spcPts val="1200"/>
               </a:spcAft>
               <a:buChar char="•"/>
+              <a:defRPr/>
             </a:lvl8pPr>
             <a:lvl9pPr marL="2667000" indent="-228600">
               <a:lnSpc>
@@ -2126,6 +2188,7 @@
                 <a:spcPts val="1200"/>
               </a:spcAft>
               <a:buChar char="•"/>
+              <a:defRPr/>
             </a:lvl9pPr>
           </a:lstStyle>
           <a:p xmlns:a="http://schemas.openxmlformats.org/drawingml/2006/main"/>
@@ -2187,6 +2250,7 @@
                 <a:spcPts val="1200"/>
               </a:spcAft>
               <a:buChar char="•"/>
+              <a:defRPr/>
             </a:lvl1pPr>
             <a:lvl2pPr marL="533400" indent="-228600">
               <a:lnSpc>
@@ -2199,6 +2263,7 @@
                 <a:spcPts val="1200"/>
               </a:spcAft>
               <a:buChar char="•"/>
+              <a:defRPr/>
             </a:lvl2pPr>
             <a:lvl3pPr marL="838200" indent="-228600">
               <a:lnSpc>
@@ -2211,6 +2276,7 @@
                 <a:spcPts val="1200"/>
               </a:spcAft>
               <a:buChar char="•"/>
+              <a:defRPr/>
             </a:lvl3pPr>
             <a:lvl4pPr marL="1143000" indent="-228600">
               <a:lnSpc>
@@ -2223,6 +2289,7 @@
                 <a:spcPts val="1200"/>
               </a:spcAft>
               <a:buChar char="•"/>
+              <a:defRPr/>
             </a:lvl4pPr>
             <a:lvl5pPr marL="1447800" indent="-228600">
               <a:lnSpc>
@@ -2235,6 +2302,7 @@
                 <a:spcPts val="1200"/>
               </a:spcAft>
               <a:buChar char="•"/>
+              <a:defRPr/>
             </a:lvl5pPr>
             <a:lvl6pPr marL="1752600" indent="-228600">
               <a:lnSpc>
@@ -2247,6 +2315,7 @@
                 <a:spcPts val="1200"/>
               </a:spcAft>
               <a:buChar char="•"/>
+              <a:defRPr/>
             </a:lvl6pPr>
             <a:lvl7pPr marL="2057400" indent="-228600">
               <a:lnSpc>
@@ -2259,6 +2328,7 @@
                 <a:spcPts val="1200"/>
               </a:spcAft>
               <a:buChar char="•"/>
+              <a:defRPr/>
             </a:lvl7pPr>
             <a:lvl8pPr marL="2362200" indent="-228600">
               <a:lnSpc>
@@ -2271,6 +2341,7 @@
                 <a:spcPts val="1200"/>
               </a:spcAft>
               <a:buChar char="•"/>
+              <a:defRPr/>
             </a:lvl8pPr>
             <a:lvl9pPr marL="2667000" indent="-228600">
               <a:lnSpc>
@@ -2283,6 +2354,7 @@
                 <a:spcPts val="1200"/>
               </a:spcAft>
               <a:buChar char="•"/>
+              <a:defRPr/>
             </a:lvl9pPr>
           </a:lstStyle>
           <a:p xmlns:a="http://schemas.openxmlformats.org/drawingml/2006/main"/>
@@ -2361,6 +2433,7 @@
                 <a:spcPts val="0"/>
               </a:spcAft>
               <a:buNone/>
+              <a:defRPr/>
             </a:lvl1pPr>
             <a:lvl2pPr marL="0" indent="0">
               <a:lnSpc>
@@ -2373,6 +2446,7 @@
                 <a:spcPts val="0"/>
               </a:spcAft>
               <a:buNone/>
+              <a:defRPr/>
             </a:lvl2pPr>
             <a:lvl3pPr marL="0" indent="0">
               <a:lnSpc>
@@ -2385,6 +2459,7 @@
                 <a:spcPts val="0"/>
               </a:spcAft>
               <a:buNone/>
+              <a:defRPr/>
             </a:lvl3pPr>
             <a:lvl4pPr marL="0" indent="0">
               <a:lnSpc>
@@ -2397,6 +2472,7 @@
                 <a:spcPts val="0"/>
               </a:spcAft>
               <a:buNone/>
+              <a:defRPr/>
             </a:lvl4pPr>
             <a:lvl5pPr marL="0" indent="0">
               <a:lnSpc>
@@ -2409,6 +2485,7 @@
                 <a:spcPts val="0"/>
               </a:spcAft>
               <a:buNone/>
+              <a:defRPr/>
             </a:lvl5pPr>
             <a:lvl6pPr marL="0" indent="0">
               <a:lnSpc>
@@ -2421,6 +2498,7 @@
                 <a:spcPts val="0"/>
               </a:spcAft>
               <a:buNone/>
+              <a:defRPr/>
             </a:lvl6pPr>
             <a:lvl7pPr marL="0" indent="0">
               <a:lnSpc>
@@ -2433,6 +2511,7 @@
                 <a:spcPts val="0"/>
               </a:spcAft>
               <a:buNone/>
+              <a:defRPr/>
             </a:lvl7pPr>
             <a:lvl8pPr marL="0" indent="0">
               <a:lnSpc>
@@ -2445,6 +2524,7 @@
                 <a:spcPts val="0"/>
               </a:spcAft>
               <a:buNone/>
+              <a:defRPr/>
             </a:lvl8pPr>
             <a:lvl9pPr marL="0" indent="0">
               <a:lnSpc>
@@ -2457,6 +2537,7 @@
                 <a:spcPts val="0"/>
               </a:spcAft>
               <a:buNone/>
+              <a:defRPr/>
             </a:lvl9pPr>
           </a:lstStyle>
           <a:p xmlns:a="http://schemas.openxmlformats.org/drawingml/2006/main"/>
@@ -2518,6 +2599,7 @@
                 <a:spcPts val="1200"/>
               </a:spcAft>
               <a:buChar char="•"/>
+              <a:defRPr/>
             </a:lvl1pPr>
             <a:lvl2pPr marL="533400" indent="-228600">
               <a:lnSpc>
@@ -2530,6 +2612,7 @@
                 <a:spcPts val="1200"/>
               </a:spcAft>
               <a:buChar char="•"/>
+              <a:defRPr/>
             </a:lvl2pPr>
             <a:lvl3pPr marL="838200" indent="-228600">
               <a:lnSpc>
@@ -2542,6 +2625,7 @@
                 <a:spcPts val="1200"/>
               </a:spcAft>
               <a:buChar char="•"/>
+              <a:defRPr/>
             </a:lvl3pPr>
             <a:lvl4pPr marL="1143000" indent="-228600">
               <a:lnSpc>
@@ -2554,6 +2638,7 @@
                 <a:spcPts val="1200"/>
               </a:spcAft>
               <a:buChar char="•"/>
+              <a:defRPr/>
             </a:lvl4pPr>
             <a:lvl5pPr marL="1447800" indent="-228600">
               <a:lnSpc>
@@ -2566,6 +2651,7 @@
                 <a:spcPts val="1200"/>
               </a:spcAft>
               <a:buChar char="•"/>
+              <a:defRPr/>
             </a:lvl5pPr>
             <a:lvl6pPr marL="1752600" indent="-228600">
               <a:lnSpc>
@@ -2578,6 +2664,7 @@
                 <a:spcPts val="1200"/>
               </a:spcAft>
               <a:buChar char="•"/>
+              <a:defRPr/>
             </a:lvl6pPr>
             <a:lvl7pPr marL="2057400" indent="-228600">
               <a:lnSpc>
@@ -2590,6 +2677,7 @@
                 <a:spcPts val="1200"/>
               </a:spcAft>
               <a:buChar char="•"/>
+              <a:defRPr/>
             </a:lvl7pPr>
             <a:lvl8pPr marL="2362200" indent="-228600">
               <a:lnSpc>
@@ -2602,6 +2690,7 @@
                 <a:spcPts val="1200"/>
               </a:spcAft>
               <a:buChar char="•"/>
+              <a:defRPr/>
             </a:lvl8pPr>
             <a:lvl9pPr marL="2667000" indent="-228600">
               <a:lnSpc>
@@ -2614,6 +2703,7 @@
                 <a:spcPts val="1200"/>
               </a:spcAft>
               <a:buChar char="•"/>
+              <a:defRPr/>
             </a:lvl9pPr>
           </a:lstStyle>
           <a:p xmlns:a="http://schemas.openxmlformats.org/drawingml/2006/main"/>
@@ -2662,12 +2752,12 @@
   </p:cSld>
   <p:clrMap bg1="lt1" tx1="dk1" bg2="lt2" tx2="dk2" accent1="accent1" accent2="accent2" accent3="accent3" accent4="accent4" accent5="accent5" accent6="accent6" hlink="hlink" folHlink="folHlink"/>
   <p:sldLayoutIdLst>
-    <p:sldLayoutId xmlns:r="http://schemas.openxmlformats.org/officeDocument/2006/relationships" id="2147483649" r:id="Rc54b7506070a4498"/>
-    <p:sldLayoutId xmlns:r="http://schemas.openxmlformats.org/officeDocument/2006/relationships" id="2147483650" r:id="R62779636b6da4b81"/>
-    <p:sldLayoutId xmlns:r="http://schemas.openxmlformats.org/officeDocument/2006/relationships" id="2147483651" r:id="R7ba60b01033b46db"/>
-    <p:sldLayoutId xmlns:r="http://schemas.openxmlformats.org/officeDocument/2006/relationships" id="2147483652" r:id="R948298a5e5e848a6"/>
-    <p:sldLayoutId xmlns:r="http://schemas.openxmlformats.org/officeDocument/2006/relationships" id="2147483653" r:id="Rd30e3e52b8b6460f"/>
-    <p:sldLayoutId xmlns:r="http://schemas.openxmlformats.org/officeDocument/2006/relationships" id="2147483654" r:id="R33afba183a8f426e"/>
+    <p:sldLayoutId xmlns:r="http://schemas.openxmlformats.org/officeDocument/2006/relationships" id="2147483649" r:id="R132b067579894def"/>
+    <p:sldLayoutId xmlns:r="http://schemas.openxmlformats.org/officeDocument/2006/relationships" id="2147483650" r:id="R4046c66dad2e4e4d"/>
+    <p:sldLayoutId xmlns:r="http://schemas.openxmlformats.org/officeDocument/2006/relationships" id="2147483651" r:id="Re7671b1d65074b23"/>
+    <p:sldLayoutId xmlns:r="http://schemas.openxmlformats.org/officeDocument/2006/relationships" id="2147483652" r:id="R574b9ee06a5a4197"/>
+    <p:sldLayoutId xmlns:r="http://schemas.openxmlformats.org/officeDocument/2006/relationships" id="2147483653" r:id="Rcdbbfdbe19804955"/>
+    <p:sldLayoutId xmlns:r="http://schemas.openxmlformats.org/officeDocument/2006/relationships" id="2147483654" r:id="R341b6992464b4f15"/>
   </p:sldLayoutIdLst>
   <p:txStyles>
     <p:titleStyle>
@@ -3256,6 +3346,7 @@
           </a:lstStyle>
           <a:p xmlns:a="http://schemas.openxmlformats.org/drawingml/2006/main">
             <a:pPr>
+              <a:buNone/>
               <a:defRPr sz="1200" b="1">
                 <a:solidFill>
                   <a:srgbClr val="70E4B7"/>
@@ -3322,6 +3413,7 @@
           </a:lstStyle>
           <a:p xmlns:a="http://schemas.openxmlformats.org/drawingml/2006/main">
             <a:pPr>
+              <a:buNone/>
               <a:defRPr sz="3675" b="1">
                 <a:solidFill>
                   <a:srgbClr val="FFFFFF"/>
@@ -3340,11 +3432,12 @@
                 <a:ea typeface="Arial"/>
                 <a:cs typeface="Arial"/>
               </a:rPr>
-              <a:t>Упреждающее управление</a:t>
+              <a:t>OQIM AI</a:t>
             </a:r>
           </a:p>
           <a:p xmlns:a="http://schemas.openxmlformats.org/drawingml/2006/main">
             <a:pPr>
+              <a:buNone/>
               <a:defRPr sz="3675" b="1">
                 <a:solidFill>
                   <a:srgbClr val="FFFFFF"/>
@@ -3363,7 +3456,7 @@
                 <a:ea typeface="Arial"/>
                 <a:cs typeface="Arial"/>
               </a:rPr>
-              <a:t>дорожной сетью</a:t>
+              <a:t>Решения для дорожной сети</a:t>
             </a:r>
           </a:p>
         </p:txBody>
@@ -3411,6 +3504,7 @@
           </a:lstStyle>
           <a:p xmlns:a="http://schemas.openxmlformats.org/drawingml/2006/main">
             <a:pPr>
+              <a:buNone/>
               <a:defRPr sz="2100" b="0">
                 <a:solidFill>
                   <a:srgbClr val="DDE8F0"/>
@@ -3429,11 +3523,12 @@
                 <a:ea typeface="Arial"/>
                 <a:cs typeface="Arial"/>
               </a:rPr>
-              <a:t>Работающий исследовательский прототип</a:t>
+              <a:t>Измеряем поток на видео и проверяем последствия решений</a:t>
             </a:r>
           </a:p>
           <a:p xmlns:a="http://schemas.openxmlformats.org/drawingml/2006/main">
             <a:pPr>
+              <a:buNone/>
               <a:defRPr sz="2100" b="0">
                 <a:solidFill>
                   <a:srgbClr val="DDE8F0"/>
@@ -3452,7 +3547,7 @@
                 <a:ea typeface="Arial"/>
                 <a:cs typeface="Arial"/>
               </a:rPr>
-              <a:t>Видеоаналитика, прогноз очередей и проверка светофорных решений</a:t>
+              <a:t>для нескольких связанных участков.</a:t>
             </a:r>
           </a:p>
           <a:p xmlns:a="http://schemas.openxmlformats.org/drawingml/2006/main">
@@ -3462,6 +3557,7 @@
           </a:p>
           <a:p xmlns:a="http://schemas.openxmlformats.org/drawingml/2006/main">
             <a:pPr>
+              <a:buNone/>
               <a:defRPr sz="2100" b="0">
                 <a:solidFill>
                   <a:srgbClr val="DDE8F0"/>
@@ -3480,7 +3576,31 @@
                 <a:ea typeface="Arial"/>
                 <a:cs typeface="Arial"/>
               </a:rPr>
-              <a:t>Покупатель: транспортный оператор или интегратор</a:t>
+              <a:t>Startup. Покупатель: транспортный оператор или интегратор.</a:t>
+            </a:r>
+          </a:p>
+          <a:p xmlns:a="http://schemas.openxmlformats.org/drawingml/2006/main">
+            <a:pPr>
+              <a:buNone/>
+              <a:defRPr sz="2100" b="0">
+                <a:solidFill>
+                  <a:srgbClr val="DDE8F0"/>
+                </a:solidFill>
+                <a:latin typeface="Arial"/>
+                <a:ea typeface="Arial"/>
+                <a:cs typeface="Arial"/>
+              </a:defRPr>
+            </a:pPr>
+            <a:r>
+              <a:rPr sz="2100" b="0">
+                <a:solidFill>
+                  <a:srgbClr val="DDE8F0"/>
+                </a:solidFill>
+                <a:latin typeface="Arial"/>
+                <a:ea typeface="Arial"/>
+                <a:cs typeface="Arial"/>
+              </a:rPr>
+              <a:t>Исследовательский прототип, реальные светофоры не подключены.</a:t>
             </a:r>
           </a:p>
         </p:txBody>
@@ -3528,6 +3648,7 @@
           </a:lstStyle>
           <a:p xmlns:a="http://schemas.openxmlformats.org/drawingml/2006/main">
             <a:pPr>
+              <a:buNone/>
               <a:defRPr sz="1050" b="0">
                 <a:solidFill>
                   <a:srgbClr val="8C9BAA"/>
@@ -3623,6 +3744,7 @@
           </a:lstStyle>
           <a:p xmlns:a="http://schemas.openxmlformats.org/drawingml/2006/main">
             <a:pPr>
+              <a:buNone/>
               <a:defRPr sz="1200" b="1">
                 <a:solidFill>
                   <a:srgbClr val="70E4B7"/>
@@ -3689,6 +3811,7 @@
           </a:lstStyle>
           <a:p xmlns:a="http://schemas.openxmlformats.org/drawingml/2006/main">
             <a:pPr>
+              <a:buNone/>
               <a:defRPr sz="3675" b="1">
                 <a:solidFill>
                   <a:srgbClr val="FFFFFF"/>
@@ -3707,7 +3830,7 @@
                 <a:ea typeface="Arial"/>
                 <a:cs typeface="Arial"/>
               </a:rPr>
-              <a:t>Проблема и первый покупатель</a:t>
+              <a:t>Покупатель и его решение</a:t>
             </a:r>
           </a:p>
         </p:txBody>
@@ -3755,6 +3878,7 @@
           </a:lstStyle>
           <a:p xmlns:a="http://schemas.openxmlformats.org/drawingml/2006/main">
             <a:pPr>
+              <a:buNone/>
               <a:defRPr sz="2100" b="0">
                 <a:solidFill>
                   <a:srgbClr val="DDE8F0"/>
@@ -3773,11 +3897,12 @@
                 <a:ea typeface="Arial"/>
                 <a:cs typeface="Arial"/>
               </a:rPr>
-              <a:t>Локальное увеличение зелёного может заполнить следующую дорогу.</a:t>
+              <a:t>Оператору нужно уменьшить очередь, не перегрузив соседний участок.</a:t>
             </a:r>
           </a:p>
           <a:p xmlns:a="http://schemas.openxmlformats.org/drawingml/2006/main">
             <a:pPr>
+              <a:buNone/>
               <a:defRPr sz="2100" b="0">
                 <a:solidFill>
                   <a:srgbClr val="DDE8F0"/>
@@ -3796,7 +3921,7 @@
                 <a:ea typeface="Arial"/>
                 <a:cs typeface="Arial"/>
               </a:rPr>
-              <a:t>Оператору нужна оценка последствий для связанной сети.</a:t>
+              <a:t>OQIM сравнивает варианты при одинаковом входном потоке.</a:t>
             </a:r>
           </a:p>
           <a:p xmlns:a="http://schemas.openxmlformats.org/drawingml/2006/main">
@@ -3806,6 +3931,7 @@
           </a:p>
           <a:p xmlns:a="http://schemas.openxmlformats.org/drawingml/2006/main">
             <a:pPr>
+              <a:buNone/>
               <a:defRPr sz="2100" b="0">
                 <a:solidFill>
                   <a:srgbClr val="DDE8F0"/>
@@ -3824,11 +3950,12 @@
                 <a:ea typeface="Arial"/>
                 <a:cs typeface="Arial"/>
               </a:rPr>
-              <a:t>Первый пилот: несколько перекрёстков или подъезд к объекту.</a:t>
+              <a:t>Первый объект: въезд и 2–4 соседних регулируемых узла.</a:t>
             </a:r>
           </a:p>
           <a:p xmlns:a="http://schemas.openxmlformats.org/drawingml/2006/main">
             <a:pPr>
+              <a:buNone/>
               <a:defRPr sz="2100" b="0">
                 <a:solidFill>
                   <a:srgbClr val="DDE8F0"/>
@@ -3847,7 +3974,31 @@
                 <a:ea typeface="Arial"/>
                 <a:cs typeface="Arial"/>
               </a:rPr>
-              <a:t>Парковочная аналитика остаётся отдельным коммерческим направлением.</a:t>
+              <a:t>Покупатель оплачивает настройку камер и проверяемый отчёт.</a:t>
+            </a:r>
+          </a:p>
+          <a:p xmlns:a="http://schemas.openxmlformats.org/drawingml/2006/main">
+            <a:pPr>
+              <a:buNone/>
+              <a:defRPr sz="2100" b="0">
+                <a:solidFill>
+                  <a:srgbClr val="DDE8F0"/>
+                </a:solidFill>
+                <a:latin typeface="Arial"/>
+                <a:ea typeface="Arial"/>
+                <a:cs typeface="Arial"/>
+              </a:defRPr>
+            </a:pPr>
+            <a:r>
+              <a:rPr sz="2100" b="0">
+                <a:solidFill>
+                  <a:srgbClr val="DDE8F0"/>
+                </a:solidFill>
+                <a:latin typeface="Arial"/>
+                <a:ea typeface="Arial"/>
+                <a:cs typeface="Arial"/>
+              </a:rPr>
+              <a:t>Спрос и готовность платить предстоит подтвердить пилотом.</a:t>
             </a:r>
           </a:p>
         </p:txBody>
@@ -3895,6 +4046,7 @@
           </a:lstStyle>
           <a:p xmlns:a="http://schemas.openxmlformats.org/drawingml/2006/main">
             <a:pPr>
+              <a:buNone/>
               <a:defRPr sz="1050" b="0">
                 <a:solidFill>
                   <a:srgbClr val="8C9BAA"/>
@@ -3990,6 +4142,7 @@
           </a:lstStyle>
           <a:p xmlns:a="http://schemas.openxmlformats.org/drawingml/2006/main">
             <a:pPr>
+              <a:buNone/>
               <a:defRPr sz="1200" b="1">
                 <a:solidFill>
                   <a:srgbClr val="70E4B7"/>
@@ -4056,6 +4209,7 @@
           </a:lstStyle>
           <a:p xmlns:a="http://schemas.openxmlformats.org/drawingml/2006/main">
             <a:pPr>
+              <a:buNone/>
               <a:defRPr sz="3675" b="1">
                 <a:solidFill>
                   <a:srgbClr val="FFFFFF"/>
@@ -4074,7 +4228,7 @@
                 <a:ea typeface="Arial"/>
                 <a:cs typeface="Arial"/>
               </a:rPr>
-              <a:t>Живое демо на новом входе</a:t>
+              <a:t>Живое демо на новом видео</a:t>
             </a:r>
           </a:p>
         </p:txBody>
@@ -4095,8 +4249,8 @@
         </p:nvSpPr>
         <p:spPr>
           <a:xfrm xmlns:a="http://schemas.openxmlformats.org/drawingml/2006/main">
-            <a:off x="609600" y="2476500"/>
-            <a:ext cx="10668000" cy="3429000"/>
+            <a:off x="609600" y="2333625"/>
+            <a:ext cx="4191000" cy="3476625"/>
           </a:xfrm>
           <a:prstGeom xmlns:a="http://schemas.openxmlformats.org/drawingml/2006/main" prst="rect">
             <a:avLst/>
@@ -4122,6 +4276,7 @@
           </a:lstStyle>
           <a:p xmlns:a="http://schemas.openxmlformats.org/drawingml/2006/main">
             <a:pPr>
+              <a:buNone/>
               <a:defRPr sz="2100" b="0">
                 <a:solidFill>
                   <a:srgbClr val="DDE8F0"/>
@@ -4140,11 +4295,12 @@
                 <a:ea typeface="Arial"/>
                 <a:cs typeface="Arial"/>
               </a:rPr>
-              <a:t>1. Загрузить разрешённое видео и задать линию учёта.</a:t>
+              <a:t>1. Видео с устройства жюри.</a:t>
             </a:r>
           </a:p>
           <a:p xmlns:a="http://schemas.openxmlformats.org/drawingml/2006/main">
             <a:pPr>
+              <a:buNone/>
               <a:defRPr sz="2100" b="0">
                 <a:solidFill>
                   <a:srgbClr val="DDE8F0"/>
@@ -4163,11 +4319,12 @@
                 <a:ea typeface="Arial"/>
                 <a:cs typeface="Arial"/>
               </a:rPr>
-              <a:t>2. Получить измеренный поток и скорость обработки.</a:t>
+              <a:t>2. Отрезок и направление.</a:t>
             </a:r>
           </a:p>
           <a:p xmlns:a="http://schemas.openxmlformats.org/drawingml/2006/main">
             <a:pPr>
+              <a:buNone/>
               <a:defRPr sz="2100" b="0">
                 <a:solidFill>
                   <a:srgbClr val="DDE8F0"/>
@@ -4186,11 +4343,12 @@
                 <a:ea typeface="Arial"/>
                 <a:cs typeface="Arial"/>
               </a:rPr>
-              <a:t>3. Передать поток в сеть и рассчитать три режима.</a:t>
+              <a:t>3. Подсчёт и скорость.</a:t>
             </a:r>
           </a:p>
           <a:p xmlns:a="http://schemas.openxmlformats.org/drawingml/2006/main">
             <a:pPr>
+              <a:buNone/>
               <a:defRPr sz="2100" b="0">
                 <a:solidFill>
                   <a:srgbClr val="DDE8F0"/>
@@ -4209,7 +4367,7 @@
                 <a:ea typeface="Arial"/>
                 <a:cs typeface="Arial"/>
               </a:rPr>
-              <a:t>4. Изменить спрос или блокировку, скачать полный отчёт.</a:t>
+              <a:t>4. Три режима и экспорт.</a:t>
             </a:r>
           </a:p>
           <a:p xmlns:a="http://schemas.openxmlformats.org/drawingml/2006/main">
@@ -4219,6 +4377,7 @@
           </a:p>
           <a:p xmlns:a="http://schemas.openxmlformats.org/drawingml/2006/main">
             <a:pPr>
+              <a:buNone/>
               <a:defRPr sz="2100" b="0">
                 <a:solidFill>
                   <a:srgbClr val="DDE8F0"/>
@@ -4237,7 +4396,55 @@
                 <a:ea typeface="Arial"/>
                 <a:cs typeface="Arial"/>
               </a:rPr>
-              <a:t>Видео обрабатывается на устройстве пользователя.</a:t>
+              <a:t>Вычисления локальные.</a:t>
+            </a:r>
+          </a:p>
+          <a:p xmlns:a="http://schemas.openxmlformats.org/drawingml/2006/main">
+            <a:pPr>
+              <a:buNone/>
+              <a:defRPr sz="2100" b="0">
+                <a:solidFill>
+                  <a:srgbClr val="DDE8F0"/>
+                </a:solidFill>
+                <a:latin typeface="Arial"/>
+                <a:ea typeface="Arial"/>
+                <a:cs typeface="Arial"/>
+              </a:defRPr>
+            </a:pPr>
+            <a:r>
+              <a:rPr sz="2100" b="0">
+                <a:solidFill>
+                  <a:srgbClr val="DDE8F0"/>
+                </a:solidFill>
+                <a:latin typeface="Arial"/>
+                <a:ea typeface="Arial"/>
+                <a:cs typeface="Arial"/>
+              </a:rPr>
+              <a:t>Первый запуск: ≈46 МБ.</a:t>
+            </a:r>
+          </a:p>
+          <a:p xmlns:a="http://schemas.openxmlformats.org/drawingml/2006/main">
+            <a:pPr>
+              <a:buNone/>
+              <a:defRPr sz="2100" b="0">
+                <a:solidFill>
+                  <a:srgbClr val="DDE8F0"/>
+                </a:solidFill>
+                <a:latin typeface="Arial"/>
+                <a:ea typeface="Arial"/>
+                <a:cs typeface="Arial"/>
+              </a:defRPr>
+            </a:pPr>
+            <a:r>
+              <a:rPr sz="2100" b="0">
+                <a:solidFill>
+                  <a:srgbClr val="DDE8F0"/>
+                </a:solidFill>
+                <a:latin typeface="Arial"/>
+                <a:ea typeface="Arial"/>
+                <a:cs typeface="Arial"/>
+              </a:rPr>
+              <a:t>Перед защитой прогреть кэш.</a:t>
             </a:r>
           </a:p>
         </p:txBody>
@@ -4285,6 +4492,7 @@
           </a:lstStyle>
           <a:p xmlns:a="http://schemas.openxmlformats.org/drawingml/2006/main">
             <a:pPr>
+              <a:buNone/>
               <a:defRPr sz="1050" b="0">
                 <a:solidFill>
                   <a:srgbClr val="8C9BAA"/>
@@ -4308,6 +4516,34 @@
           </a:p>
         </p:txBody>
       </p:sp>
+      <p:pic>
+        <p:nvPicPr>
+          <p:cNvPr id="6" name="">
+            <a:extLst xmlns:a="http://schemas.openxmlformats.org/drawingml/2006/main">
+              <a:ext uri="{FF2B5EF4-FFF2-40B4-BE49-F238E27FC236}">
+                <a16:creationId xmlns:a16="http://schemas.microsoft.com/office/drawing/2014/main" id="{D416874F-9AA5-42AE-A7BA-08A3862EED85}"/>
+              </a:ext>
+            </a:extLst>
+          </p:cNvPr>
+          <p:cNvPicPr>
+            <a:picLocks xmlns:a="http://schemas.openxmlformats.org/drawingml/2006/main" noChangeAspect="1"/>
+          </p:cNvPicPr>
+          <p:nvPr/>
+        </p:nvPicPr>
+        <p:blipFill>
+          <a:blip xmlns:r="http://schemas.openxmlformats.org/officeDocument/2006/relationships" xmlns:a="http://schemas.openxmlformats.org/drawingml/2006/main" r:embed="Rb5d46d5fc41e451b"/>
+          <a:stretch xmlns:a="http://schemas.openxmlformats.org/drawingml/2006/main"/>
+        </p:blipFill>
+        <p:spPr>
+          <a:xfrm xmlns:a="http://schemas.openxmlformats.org/drawingml/2006/main">
+            <a:off x="5048250" y="2240756"/>
+            <a:ext cx="6477000" cy="3643313"/>
+          </a:xfrm>
+          <a:prstGeom xmlns:a="http://schemas.openxmlformats.org/drawingml/2006/main" prst="rect">
+            <a:avLst/>
+          </a:prstGeom>
+        </p:spPr>
+      </p:pic>
     </p:spTree>
     <p:extLst>
       <p:ext uri="{BB962C8B-B14F-4D97-AF65-F5344CB8AC3E}">
@@ -4380,6 +4616,7 @@
           </a:lstStyle>
           <a:p xmlns:a="http://schemas.openxmlformats.org/drawingml/2006/main">
             <a:pPr>
+              <a:buNone/>
               <a:defRPr sz="1200" b="1">
                 <a:solidFill>
                   <a:srgbClr val="70E4B7"/>
@@ -4446,6 +4683,7 @@
           </a:lstStyle>
           <a:p xmlns:a="http://schemas.openxmlformats.org/drawingml/2006/main">
             <a:pPr>
+              <a:buNone/>
               <a:defRPr sz="3675" b="1">
                 <a:solidFill>
                   <a:srgbClr val="FFFFFF"/>
@@ -4464,7 +4702,7 @@
                 <a:ea typeface="Arial"/>
                 <a:cs typeface="Arial"/>
               </a:rPr>
-              <a:t>Технология и происхождение кода</a:t>
+              <a:t>Технология и вклад команды</a:t>
             </a:r>
           </a:p>
         </p:txBody>
@@ -4512,6 +4750,7 @@
           </a:lstStyle>
           <a:p xmlns:a="http://schemas.openxmlformats.org/drawingml/2006/main">
             <a:pPr>
+              <a:buNone/>
               <a:defRPr sz="2100" b="0">
                 <a:solidFill>
                   <a:srgbClr val="DDE8F0"/>
@@ -4530,11 +4769,12 @@
                 <a:ea typeface="Arial"/>
                 <a:cs typeface="Arial"/>
               </a:rPr>
-              <a:t>Открытые детектор и ByteTrack преобразуют видео в поток.</a:t>
+              <a:t>YOLO26s и ByteTrack: открытая детекция и трекинг из PariVision.</a:t>
             </a:r>
           </a:p>
           <a:p xmlns:a="http://schemas.openxmlformats.org/drawingml/2006/main">
             <a:pPr>
+              <a:buNone/>
               <a:defRPr sz="2100" b="0">
                 <a:solidFill>
                   <a:srgbClr val="DDE8F0"/>
@@ -4553,11 +4793,12 @@
                 <a:ea typeface="Arial"/>
                 <a:cs typeface="Arial"/>
               </a:rPr>
-              <a:t>Сетевая модель учитывает очереди, вместимость и время проезда.</a:t>
+              <a:t>OQIM: отрезок учёта, направления и неопределённость замера.</a:t>
             </a:r>
           </a:p>
           <a:p xmlns:a="http://schemas.openxmlformats.org/drawingml/2006/main">
             <a:pPr>
+              <a:buNone/>
               <a:defRPr sz="2100" b="0">
                 <a:solidFill>
                   <a:srgbClr val="DDE8F0"/>
@@ -4576,16 +4817,41 @@
                 <a:ea typeface="Arial"/>
                 <a:cs typeface="Arial"/>
               </a:rPr>
-              <a:t>Оптимизатор проверяет длительности зелёного на горизонте 90 с.</a:t>
-            </a:r>
-          </a:p>
-          <a:p xmlns:a="http://schemas.openxmlformats.org/drawingml/2006/main">
-            <a:r>
+              <a:t>Сеть: конечная вместимость, очереди и время проезда.</a:t>
+            </a:r>
+          </a:p>
+          <a:p xmlns:a="http://schemas.openxmlformats.org/drawingml/2006/main">
+            <a:r>
+              <a:t>Оптимизатор сравнивает зелёные фазы на 90 секунд вперёд.</a:t>
+            </a:r>
+          </a:p>
+          <a:p xmlns:a="http://schemas.openxmlformats.org/drawingml/2006/main">
+            <a:pPr>
+              <a:buNone/>
+              <a:defRPr sz="2100" b="0">
+                <a:solidFill>
+                  <a:srgbClr val="DDE8F0"/>
+                </a:solidFill>
+                <a:latin typeface="Arial"/>
+                <a:ea typeface="Arial"/>
+                <a:cs typeface="Arial"/>
+              </a:defRPr>
+            </a:pPr>
+            <a:r>
+              <a:rPr sz="2100" b="0">
+                <a:solidFill>
+                  <a:srgbClr val="DDE8F0"/>
+                </a:solidFill>
+                <a:latin typeface="Arial"/>
+                <a:ea typeface="Arial"/>
+                <a:cs typeface="Arial"/>
+              </a:rPr>
               <a:t/>
             </a:r>
           </a:p>
           <a:p xmlns:a="http://schemas.openxmlformats.org/drawingml/2006/main">
             <a:pPr>
+              <a:buNone/>
               <a:defRPr sz="2100" b="0">
                 <a:solidFill>
                   <a:srgbClr val="DDE8F0"/>
@@ -4604,11 +4870,12 @@
                 <a:ea typeface="Arial"/>
                 <a:cs typeface="Arial"/>
               </a:rPr>
-              <a:t>Паривижн: переиспользованный открытый код, AGPL-3.0.</a:t>
+              <a:t>21 тест. Защитные интервалы и смена плана на границе цикла.</a:t>
             </a:r>
           </a:p>
           <a:p xmlns:a="http://schemas.openxmlformats.org/drawingml/2006/main">
             <a:pPr>
+              <a:buNone/>
               <a:defRPr sz="2100" b="0">
                 <a:solidFill>
                   <a:srgbClr val="DDE8F0"/>
@@ -4627,7 +4894,7 @@
                 <a:ea typeface="Arial"/>
                 <a:cs typeface="Arial"/>
               </a:rPr>
-              <a:t>Новые компоненты OQIM: модель сети, сравнение и интеграция.</a:t>
+              <a:t>AGPL-3.0, источники и помощь Codex раскрыты в репозитории.</a:t>
             </a:r>
           </a:p>
         </p:txBody>
@@ -4675,6 +4942,7 @@
           </a:lstStyle>
           <a:p xmlns:a="http://schemas.openxmlformats.org/drawingml/2006/main">
             <a:pPr>
+              <a:buNone/>
               <a:defRPr sz="1050" b="0">
                 <a:solidFill>
                   <a:srgbClr val="8C9BAA"/>
@@ -4770,6 +5038,7 @@
           </a:lstStyle>
           <a:p xmlns:a="http://schemas.openxmlformats.org/drawingml/2006/main">
             <a:pPr>
+              <a:buNone/>
               <a:defRPr sz="1200" b="1">
                 <a:solidFill>
                   <a:srgbClr val="70E4B7"/>
@@ -4836,6 +5105,7 @@
           </a:lstStyle>
           <a:p xmlns:a="http://schemas.openxmlformats.org/drawingml/2006/main">
             <a:pPr>
+              <a:buNone/>
               <a:defRPr sz="3675" b="1">
                 <a:solidFill>
                   <a:srgbClr val="FFFFFF"/>
@@ -4854,7 +5124,7 @@
                 <a:ea typeface="Arial"/>
                 <a:cs typeface="Arial"/>
               </a:rPr>
-              <a:t>Результат воспроизводимой симуляции</a:t>
+              <a:t>120 сценариев: эффект и границы</a:t>
             </a:r>
           </a:p>
         </p:txBody>
@@ -4875,8 +5145,8 @@
         </p:nvSpPr>
         <p:spPr>
           <a:xfrm xmlns:a="http://schemas.openxmlformats.org/drawingml/2006/main">
-            <a:off x="609600" y="2476500"/>
-            <a:ext cx="10668000" cy="3429000"/>
+            <a:off x="609600" y="2238375"/>
+            <a:ext cx="10763250" cy="904875"/>
           </a:xfrm>
           <a:prstGeom xmlns:a="http://schemas.openxmlformats.org/drawingml/2006/main" prst="rect">
             <a:avLst/>
@@ -4902,6 +5172,7 @@
           </a:lstStyle>
           <a:p xmlns:a="http://schemas.openxmlformats.org/drawingml/2006/main">
             <a:pPr>
+              <a:buNone/>
               <a:defRPr sz="2100" b="0">
                 <a:solidFill>
                   <a:srgbClr val="DDE8F0"/>
@@ -4920,109 +5191,12 @@
                 <a:ea typeface="Arial"/>
                 <a:cs typeface="Arial"/>
               </a:rPr>
-              <a:t>4 узла, 10 минут, seed 42, основной вход 650 машин/ч</a:t>
-            </a:r>
-          </a:p>
-          <a:p xmlns:a="http://schemas.openxmlformats.org/drawingml/2006/main">
-            <a:r>
-              <a:t/>
-            </a:r>
-          </a:p>
-          <a:p xmlns:a="http://schemas.openxmlformats.org/drawingml/2006/main">
-            <a:pPr>
-              <a:defRPr sz="2100" b="0">
-                <a:solidFill>
-                  <a:srgbClr val="DDE8F0"/>
-                </a:solidFill>
-                <a:latin typeface="Arial"/>
-                <a:ea typeface="Arial"/>
-                <a:cs typeface="Arial"/>
-              </a:defRPr>
-            </a:pPr>
-            <a:r>
-              <a:rPr sz="2100" b="0">
-                <a:solidFill>
-                  <a:srgbClr val="DDE8F0"/>
-                </a:solidFill>
-                <a:latin typeface="Arial"/>
-                <a:ea typeface="Arial"/>
-                <a:cs typeface="Arial"/>
-              </a:rPr>
-              <a:t>Фиксированный режим: 18.2 с задержки на машину</a:t>
-            </a:r>
-          </a:p>
-          <a:p xmlns:a="http://schemas.openxmlformats.org/drawingml/2006/main">
-            <a:pPr>
-              <a:defRPr sz="2100" b="0">
-                <a:solidFill>
-                  <a:srgbClr val="DDE8F0"/>
-                </a:solidFill>
-                <a:latin typeface="Arial"/>
-                <a:ea typeface="Arial"/>
-                <a:cs typeface="Arial"/>
-              </a:defRPr>
-            </a:pPr>
-            <a:r>
-              <a:rPr sz="2100" b="0">
-                <a:solidFill>
-                  <a:srgbClr val="DDE8F0"/>
-                </a:solidFill>
-                <a:latin typeface="Arial"/>
-                <a:ea typeface="Arial"/>
-                <a:cs typeface="Arial"/>
-              </a:rPr>
-              <a:t>Реактивный режим: 19.6 с</a:t>
-            </a:r>
-          </a:p>
-          <a:p xmlns:a="http://schemas.openxmlformats.org/drawingml/2006/main">
-            <a:pPr>
-              <a:defRPr sz="2100" b="0">
-                <a:solidFill>
-                  <a:srgbClr val="DDE8F0"/>
-                </a:solidFill>
-                <a:latin typeface="Arial"/>
-                <a:ea typeface="Arial"/>
-                <a:cs typeface="Arial"/>
-              </a:defRPr>
-            </a:pPr>
-            <a:r>
-              <a:rPr sz="2100" b="0">
-                <a:solidFill>
-                  <a:srgbClr val="DDE8F0"/>
-                </a:solidFill>
-                <a:latin typeface="Arial"/>
-                <a:ea typeface="Arial"/>
-                <a:cs typeface="Arial"/>
-              </a:rPr>
-              <a:t>OQIM: 15.9 с (12.6% меньше фиксированного)</a:t>
-            </a:r>
-          </a:p>
-          <a:p xmlns:a="http://schemas.openxmlformats.org/drawingml/2006/main">
-            <a:r>
-              <a:t/>
-            </a:r>
-          </a:p>
-          <a:p xmlns:a="http://schemas.openxmlformats.org/drawingml/2006/main">
-            <a:pPr>
-              <a:defRPr sz="2100" b="0">
-                <a:solidFill>
-                  <a:srgbClr val="DDE8F0"/>
-                </a:solidFill>
-                <a:latin typeface="Arial"/>
-                <a:ea typeface="Arial"/>
-                <a:cs typeface="Arial"/>
-              </a:defRPr>
-            </a:pPr>
-            <a:r>
-              <a:rPr sz="2100" b="0">
-                <a:solidFill>
-                  <a:srgbClr val="DDE8F0"/>
-                </a:solidFill>
-                <a:latin typeface="Arial"/>
-                <a:ea typeface="Arial"/>
-                <a:cs typeface="Arial"/>
-              </a:rPr>
-              <a:t>Синтетический сценарий. Эффект в реальном городе не установлен.</a:t>
+              <a:t>4 интенсивности × 2 боковых потока × 3 условия × 5 seeds</a:t>
+            </a:r>
+          </a:p>
+          <a:p xmlns:a="http://schemas.openxmlformats.org/drawingml/2006/main">
+            <a:r>
+              <a:t>4 узла, 10 минут. Все исходы включены, входы одинаковы.</a:t>
             </a:r>
           </a:p>
         </p:txBody>
@@ -5070,6 +5244,7 @@
           </a:lstStyle>
           <a:p xmlns:a="http://schemas.openxmlformats.org/drawingml/2006/main">
             <a:pPr>
+              <a:buNone/>
               <a:defRPr sz="1050" b="0">
                 <a:solidFill>
                   <a:srgbClr val="8C9BAA"/>
@@ -5089,6 +5264,396 @@
                 <a:cs typeface="Arial"/>
               </a:rPr>
               <a:t>5 / 8</a:t>
+            </a:r>
+          </a:p>
+        </p:txBody>
+      </p:sp>
+      <p:graphicFrame>
+        <p:nvGraphicFramePr>
+          <p:cNvPr id="6" name="">
+            <a:extLst xmlns:a="http://schemas.openxmlformats.org/drawingml/2006/main">
+              <a:ext uri="{FF2B5EF4-FFF2-40B4-BE49-F238E27FC236}">
+                <a16:creationId xmlns:a16="http://schemas.microsoft.com/office/drawing/2014/main" id="{DD0800B9-A7E1-415D-8B34-A2CBF52AB7AC}"/>
+              </a:ext>
+            </a:extLst>
+          </p:cNvPr>
+          <p:cNvGraphicFramePr/>
+          <p:nvPr/>
+        </p:nvGraphicFramePr>
+        <p:xfrm>
+          <a:off xmlns:a="http://schemas.openxmlformats.org/drawingml/2006/main" x="609600" y="3286125"/>
+          <a:ext xmlns:a="http://schemas.openxmlformats.org/drawingml/2006/main" cx="10858500" cy="1809750"/>
+        </p:xfrm>
+        <a:graphic xmlns:a="http://schemas.openxmlformats.org/drawingml/2006/main">
+          <a:graphicData uri="http://schemas.openxmlformats.org/drawingml/2006/table">
+            <a:tbl>
+              <a:tblPr/>
+              <a:tblGrid>
+                <a:gridCol w="3286125"/>
+                <a:gridCol w="2809875"/>
+                <a:gridCol w="2333625"/>
+                <a:gridCol w="2428875"/>
+              </a:tblGrid>
+              <a:tr h="603250">
+                <a:tc>
+                  <a:txBody>
+                    <a:bodyPr/>
+                    <a:lstStyle/>
+                    <a:p>
+                      <a:r>
+                        <a:rPr sz="1650" b="1">
+                          <a:solidFill>
+                            <a:srgbClr val="8C9BAA"/>
+                          </a:solidFill>
+                          <a:latin typeface="Arial"/>
+                          <a:ea typeface="Arial"/>
+                          <a:cs typeface="Arial"/>
+                        </a:rPr>
+                        <a:t>Базовый режим</a:t>
+                      </a:r>
+                    </a:p>
+                  </a:txBody>
+                  <a:tcPr marL="91440" marR="91440" marT="45720" marB="45720">
+                    <a:solidFill>
+                      <a:srgbClr val="0B1118"/>
+                    </a:solidFill>
+                  </a:tcPr>
+                </a:tc>
+                <a:tc>
+                  <a:txBody>
+                    <a:bodyPr/>
+                    <a:lstStyle/>
+                    <a:p>
+                      <a:r>
+                        <a:rPr sz="1650" b="1">
+                          <a:solidFill>
+                            <a:srgbClr val="8C9BAA"/>
+                          </a:solidFill>
+                          <a:latin typeface="Arial"/>
+                          <a:ea typeface="Arial"/>
+                          <a:cs typeface="Arial"/>
+                        </a:rPr>
+                        <a:t>Среднее снижение</a:t>
+                      </a:r>
+                    </a:p>
+                  </a:txBody>
+                  <a:tcPr marL="91440" marR="91440" marT="45720" marB="45720">
+                    <a:solidFill>
+                      <a:srgbClr val="0B1118"/>
+                    </a:solidFill>
+                  </a:tcPr>
+                </a:tc>
+                <a:tc>
+                  <a:txBody>
+                    <a:bodyPr/>
+                    <a:lstStyle/>
+                    <a:p>
+                      <a:r>
+                        <a:rPr sz="1650" b="1">
+                          <a:solidFill>
+                            <a:srgbClr val="8C9BAA"/>
+                          </a:solidFill>
+                          <a:latin typeface="Arial"/>
+                          <a:ea typeface="Arial"/>
+                          <a:cs typeface="Arial"/>
+                        </a:rPr>
+                        <a:t>Победы / потери</a:t>
+                      </a:r>
+                    </a:p>
+                  </a:txBody>
+                  <a:tcPr marL="91440" marR="91440" marT="45720" marB="45720">
+                    <a:solidFill>
+                      <a:srgbClr val="0B1118"/>
+                    </a:solidFill>
+                  </a:tcPr>
+                </a:tc>
+                <a:tc>
+                  <a:txBody>
+                    <a:bodyPr/>
+                    <a:lstStyle/>
+                    <a:p>
+                      <a:r>
+                        <a:rPr sz="1650" b="1">
+                          <a:solidFill>
+                            <a:srgbClr val="8C9BAA"/>
+                          </a:solidFill>
+                          <a:latin typeface="Arial"/>
+                          <a:ea typeface="Arial"/>
+                          <a:cs typeface="Arial"/>
+                        </a:rPr>
+                        <a:t>Худший исход</a:t>
+                      </a:r>
+                    </a:p>
+                  </a:txBody>
+                  <a:tcPr marL="91440" marR="91440" marT="45720" marB="45720">
+                    <a:solidFill>
+                      <a:srgbClr val="0B1118"/>
+                    </a:solidFill>
+                  </a:tcPr>
+                </a:tc>
+              </a:tr>
+              <a:tr h="603250">
+                <a:tc>
+                  <a:txBody>
+                    <a:bodyPr/>
+                    <a:lstStyle/>
+                    <a:p>
+                      <a:r>
+                        <a:rPr sz="2025" b="0">
+                          <a:solidFill>
+                            <a:srgbClr val="DDE8F0"/>
+                          </a:solidFill>
+                          <a:latin typeface="Arial"/>
+                          <a:ea typeface="Arial"/>
+                          <a:cs typeface="Arial"/>
+                        </a:rPr>
+                        <a:t>Фиксированный</a:t>
+                      </a:r>
+                    </a:p>
+                  </a:txBody>
+                  <a:tcPr marL="91440" marR="91440" marT="45720" marB="45720">
+                    <a:solidFill>
+                      <a:srgbClr val="0B1118"/>
+                    </a:solidFill>
+                  </a:tcPr>
+                </a:tc>
+                <a:tc>
+                  <a:txBody>
+                    <a:bodyPr/>
+                    <a:lstStyle/>
+                    <a:p>
+                      <a:r>
+                        <a:rPr sz="2025" b="0">
+                          <a:solidFill>
+                            <a:srgbClr val="DDE8F0"/>
+                          </a:solidFill>
+                          <a:latin typeface="Arial"/>
+                          <a:ea typeface="Arial"/>
+                          <a:cs typeface="Arial"/>
+                        </a:rPr>
+                        <a:t>24.6%</a:t>
+                      </a:r>
+                    </a:p>
+                  </a:txBody>
+                  <a:tcPr marL="91440" marR="91440" marT="45720" marB="45720">
+                    <a:solidFill>
+                      <a:srgbClr val="0B1118"/>
+                    </a:solidFill>
+                  </a:tcPr>
+                </a:tc>
+                <a:tc>
+                  <a:txBody>
+                    <a:bodyPr/>
+                    <a:lstStyle/>
+                    <a:p>
+                      <a:r>
+                        <a:rPr sz="2025" b="0">
+                          <a:solidFill>
+                            <a:srgbClr val="DDE8F0"/>
+                          </a:solidFill>
+                          <a:latin typeface="Arial"/>
+                          <a:ea typeface="Arial"/>
+                          <a:cs typeface="Arial"/>
+                        </a:rPr>
+                        <a:t>104 / 16</a:t>
+                      </a:r>
+                    </a:p>
+                  </a:txBody>
+                  <a:tcPr marL="91440" marR="91440" marT="45720" marB="45720">
+                    <a:solidFill>
+                      <a:srgbClr val="0B1118"/>
+                    </a:solidFill>
+                  </a:tcPr>
+                </a:tc>
+                <a:tc>
+                  <a:txBody>
+                    <a:bodyPr/>
+                    <a:lstStyle/>
+                    <a:p>
+                      <a:r>
+                        <a:rPr sz="2025" b="0">
+                          <a:solidFill>
+                            <a:srgbClr val="DDE8F0"/>
+                          </a:solidFill>
+                          <a:latin typeface="Arial"/>
+                          <a:ea typeface="Arial"/>
+                          <a:cs typeface="Arial"/>
+                        </a:rPr>
+                        <a:t>−28,6%</a:t>
+                      </a:r>
+                    </a:p>
+                  </a:txBody>
+                  <a:tcPr marL="91440" marR="91440" marT="45720" marB="45720">
+                    <a:solidFill>
+                      <a:srgbClr val="0B1118"/>
+                    </a:solidFill>
+                  </a:tcPr>
+                </a:tc>
+              </a:tr>
+              <a:tr h="603250">
+                <a:tc>
+                  <a:txBody>
+                    <a:bodyPr/>
+                    <a:lstStyle/>
+                    <a:p>
+                      <a:r>
+                        <a:rPr sz="2025" b="0">
+                          <a:solidFill>
+                            <a:srgbClr val="DDE8F0"/>
+                          </a:solidFill>
+                          <a:latin typeface="Arial"/>
+                          <a:ea typeface="Arial"/>
+                          <a:cs typeface="Arial"/>
+                        </a:rPr>
+                        <a:t>Реактивный</a:t>
+                      </a:r>
+                    </a:p>
+                  </a:txBody>
+                  <a:tcPr marL="91440" marR="91440" marT="45720" marB="45720">
+                    <a:solidFill>
+                      <a:srgbClr val="0B1118"/>
+                    </a:solidFill>
+                  </a:tcPr>
+                </a:tc>
+                <a:tc>
+                  <a:txBody>
+                    <a:bodyPr/>
+                    <a:lstStyle/>
+                    <a:p>
+                      <a:r>
+                        <a:rPr sz="2025" b="0">
+                          <a:solidFill>
+                            <a:srgbClr val="DDE8F0"/>
+                          </a:solidFill>
+                          <a:latin typeface="Arial"/>
+                          <a:ea typeface="Arial"/>
+                          <a:cs typeface="Arial"/>
+                        </a:rPr>
+                        <a:t>20.1%</a:t>
+                      </a:r>
+                    </a:p>
+                  </a:txBody>
+                  <a:tcPr marL="91440" marR="91440" marT="45720" marB="45720">
+                    <a:solidFill>
+                      <a:srgbClr val="0B1118"/>
+                    </a:solidFill>
+                  </a:tcPr>
+                </a:tc>
+                <a:tc>
+                  <a:txBody>
+                    <a:bodyPr/>
+                    <a:lstStyle/>
+                    <a:p>
+                      <a:r>
+                        <a:rPr sz="2025" b="0">
+                          <a:solidFill>
+                            <a:srgbClr val="DDE8F0"/>
+                          </a:solidFill>
+                          <a:latin typeface="Arial"/>
+                          <a:ea typeface="Arial"/>
+                          <a:cs typeface="Arial"/>
+                        </a:rPr>
+                        <a:t>118 / 2</a:t>
+                      </a:r>
+                    </a:p>
+                  </a:txBody>
+                  <a:tcPr marL="91440" marR="91440" marT="45720" marB="45720">
+                    <a:solidFill>
+                      <a:srgbClr val="0B1118"/>
+                    </a:solidFill>
+                  </a:tcPr>
+                </a:tc>
+                <a:tc>
+                  <a:txBody>
+                    <a:bodyPr/>
+                    <a:lstStyle/>
+                    <a:p>
+                      <a:r>
+                        <a:rPr sz="2025" b="0">
+                          <a:solidFill>
+                            <a:srgbClr val="DDE8F0"/>
+                          </a:solidFill>
+                          <a:latin typeface="Arial"/>
+                          <a:ea typeface="Arial"/>
+                          <a:cs typeface="Arial"/>
+                        </a:rPr>
+                        <a:t>−11,6%</a:t>
+                      </a:r>
+                    </a:p>
+                  </a:txBody>
+                  <a:tcPr marL="91440" marR="91440" marT="45720" marB="45720">
+                    <a:solidFill>
+                      <a:srgbClr val="0B1118"/>
+                    </a:solidFill>
+                  </a:tcPr>
+                </a:tc>
+              </a:tr>
+            </a:tbl>
+          </a:graphicData>
+        </a:graphic>
+      </p:graphicFrame>
+      <p:sp>
+        <p:nvSpPr>
+          <p:cNvPr id="7" name="">
+            <a:extLst xmlns:a="http://schemas.openxmlformats.org/drawingml/2006/main">
+              <a:ext uri="{FF2B5EF4-FFF2-40B4-BE49-F238E27FC236}">
+                <a16:creationId xmlns:a16="http://schemas.microsoft.com/office/drawing/2014/main" id="{84E463F6-62DF-4E47-A92E-9E1B0AA7B059}"/>
+              </a:ext>
+            </a:extLst>
+          </p:cNvPr>
+          <p:cNvSpPr>
+            <a:spLocks xmlns:a="http://schemas.openxmlformats.org/drawingml/2006/main" noGrp="1"/>
+          </p:cNvSpPr>
+          <p:nvPr/>
+        </p:nvSpPr>
+        <p:spPr>
+          <a:xfrm xmlns:a="http://schemas.openxmlformats.org/drawingml/2006/main">
+            <a:off x="609600" y="5381625"/>
+            <a:ext cx="10858500" cy="523875"/>
+          </a:xfrm>
+          <a:prstGeom xmlns:a="http://schemas.openxmlformats.org/drawingml/2006/main" prst="rect">
+            <a:avLst/>
+          </a:prstGeom>
+          <a:noFill xmlns:a="http://schemas.openxmlformats.org/drawingml/2006/main"/>
+          <a:ln xmlns:a="http://schemas.openxmlformats.org/drawingml/2006/main" w="0">
+            <a:noFill/>
+          </a:ln>
+        </p:spPr>
+        <p:txBody>
+          <a:bodyPr xmlns:a="http://schemas.openxmlformats.org/drawingml/2006/main"/>
+          <a:lstStyle xmlns:a="http://schemas.openxmlformats.org/drawingml/2006/main">
+            <a:defPPr>
+              <a:defRPr sz="1875" b="0">
+                <a:solidFill>
+                  <a:srgbClr val="EDB96A"/>
+                </a:solidFill>
+                <a:latin typeface="Arial"/>
+                <a:ea typeface="Arial"/>
+                <a:cs typeface="Arial"/>
+              </a:defRPr>
+            </a:defPPr>
+          </a:lstStyle>
+          <a:p xmlns:a="http://schemas.openxmlformats.org/drawingml/2006/main">
+            <a:pPr>
+              <a:defRPr sz="1875" b="0">
+                <a:solidFill>
+                  <a:srgbClr val="EDB96A"/>
+                </a:solidFill>
+                <a:latin typeface="Arial"/>
+                <a:ea typeface="Arial"/>
+                <a:cs typeface="Arial"/>
+              </a:defRPr>
+            </a:pPr>
+            <a:r>
+              <a:rPr sz="1875" b="0">
+                <a:solidFill>
+                  <a:srgbClr val="EDB96A"/>
+                </a:solidFill>
+                <a:latin typeface="Arial"/>
+                <a:ea typeface="Arial"/>
+                <a:cs typeface="Arial"/>
+              </a:rPr>
+              <a:t>Минус означает рост задержки. Это симуляция, не эффект в городе.</a:t>
             </a:r>
           </a:p>
         </p:txBody>
@@ -5165,6 +5730,7 @@
           </a:lstStyle>
           <a:p xmlns:a="http://schemas.openxmlformats.org/drawingml/2006/main">
             <a:pPr>
+              <a:buNone/>
               <a:defRPr sz="1200" b="1">
                 <a:solidFill>
                   <a:srgbClr val="70E4B7"/>
@@ -5231,6 +5797,7 @@
           </a:lstStyle>
           <a:p xmlns:a="http://schemas.openxmlformats.org/drawingml/2006/main">
             <a:pPr>
+              <a:buNone/>
               <a:defRPr sz="3675" b="1">
                 <a:solidFill>
                   <a:srgbClr val="FFFFFF"/>
@@ -5249,7 +5816,7 @@
                 <a:ea typeface="Arial"/>
                 <a:cs typeface="Arial"/>
               </a:rPr>
-              <a:t>Проверка и ограничения</a:t>
+              <a:t>Видео: 16 из 17 событий</a:t>
             </a:r>
           </a:p>
         </p:txBody>
@@ -5297,6 +5864,7 @@
           </a:lstStyle>
           <a:p xmlns:a="http://schemas.openxmlformats.org/drawingml/2006/main">
             <a:pPr>
+              <a:buNone/>
               <a:defRPr sz="2100" b="0">
                 <a:solidFill>
                   <a:srgbClr val="DDE8F0"/>
@@ -5315,11 +5883,12 @@
                 <a:ea typeface="Arial"/>
                 <a:cs typeface="Arial"/>
               </a:rPr>
-              <a:t>Автотесты проверяют сохранение потока, вместимость и фазы.</a:t>
+              <a:t>A40, 24,5 с. Строгий допуск: −1 / +4 кадра при 30 fps.</a:t>
             </a:r>
           </a:p>
           <a:p xmlns:a="http://schemas.openxmlformats.org/drawingml/2006/main">
             <a:pPr>
+              <a:buNone/>
               <a:defRPr sz="2100" b="0">
                 <a:solidFill>
                   <a:srgbClr val="DDE8F0"/>
@@ -5338,11 +5907,12 @@
                 <a:ea typeface="Arial"/>
                 <a:cs typeface="Arial"/>
               </a:rPr>
-              <a:t>Все режимы получают одинаковые входные машины.</a:t>
+              <a:t>16 совпадений, 1 пропуск, 0 лишних. F1 97.0%.</a:t>
             </a:r>
           </a:p>
           <a:p xmlns:a="http://schemas.openxmlformats.org/drawingml/2006/main">
             <a:pPr>
+              <a:buNone/>
               <a:defRPr sz="2100" b="0">
                 <a:solidFill>
                   <a:srgbClr val="DDE8F0"/>
@@ -5361,7 +5931,7 @@
                 <a:ea typeface="Arial"/>
                 <a:cs typeface="Arial"/>
               </a:rPr>
-              <a:t>Незавершённые поездки и внешние очереди входят в отчёт.</a:t>
+              <a:t>Все 7 уверенных меток совпали. 10 меток из 17 вероятные.</a:t>
             </a:r>
           </a:p>
           <a:p xmlns:a="http://schemas.openxmlformats.org/drawingml/2006/main">
@@ -5371,6 +5941,7 @@
           </a:p>
           <a:p xmlns:a="http://schemas.openxmlformats.org/drawingml/2006/main">
             <a:pPr>
+              <a:buNone/>
               <a:defRPr sz="2100" b="0">
                 <a:solidFill>
                   <a:srgbClr val="DDE8F0"/>
@@ -5389,11 +5960,12 @@
                 <a:ea typeface="Arial"/>
                 <a:cs typeface="Arial"/>
               </a:rPr>
-              <a:t>Реальные светофоры не подключены.</a:t>
+              <a:t>245 кадров за 14.5 с. Apple M5, 16 ГБ, WebGPU.</a:t>
             </a:r>
           </a:p>
           <a:p xmlns:a="http://schemas.openxmlformats.org/drawingml/2006/main">
             <a:pPr>
+              <a:buNone/>
               <a:defRPr sz="2100" b="0">
                 <a:solidFill>
                   <a:srgbClr val="DDE8F0"/>
@@ -5412,7 +5984,31 @@
                 <a:ea typeface="Arial"/>
                 <a:cs typeface="Arial"/>
               </a:rPr>
-              <a:t>Ночь, дождь и местный транспорт требуют отдельной оценки качества.</a:t>
+              <a:t>Внешняя разметка: Safdar Hussain / TrafficLens, MIT.</a:t>
+            </a:r>
+          </a:p>
+          <a:p xmlns:a="http://schemas.openxmlformats.org/drawingml/2006/main">
+            <a:pPr>
+              <a:buNone/>
+              <a:defRPr sz="2100" b="0">
+                <a:solidFill>
+                  <a:srgbClr val="DDE8F0"/>
+                </a:solidFill>
+                <a:latin typeface="Arial"/>
+                <a:ea typeface="Arial"/>
+                <a:cs typeface="Arial"/>
+              </a:defRPr>
+            </a:pPr>
+            <a:r>
+              <a:rPr sz="2100" b="0">
+                <a:solidFill>
+                  <a:srgbClr val="DDE8F0"/>
+                </a:solidFill>
+                <a:latin typeface="Arial"/>
+                <a:ea typeface="Arial"/>
+                <a:cs typeface="Arial"/>
+              </a:rPr>
+              <a:t>Один дневной ролик. Ночь и местные камеры ещё не валидированы.</a:t>
             </a:r>
           </a:p>
         </p:txBody>
@@ -5460,6 +6056,7 @@
           </a:lstStyle>
           <a:p xmlns:a="http://schemas.openxmlformats.org/drawingml/2006/main">
             <a:pPr>
+              <a:buNone/>
               <a:defRPr sz="1050" b="0">
                 <a:solidFill>
                   <a:srgbClr val="8C9BAA"/>
@@ -5555,6 +6152,7 @@
           </a:lstStyle>
           <a:p xmlns:a="http://schemas.openxmlformats.org/drawingml/2006/main">
             <a:pPr>
+              <a:buNone/>
               <a:defRPr sz="1200" b="1">
                 <a:solidFill>
                   <a:srgbClr val="70E4B7"/>
@@ -5621,6 +6219,7 @@
           </a:lstStyle>
           <a:p xmlns:a="http://schemas.openxmlformats.org/drawingml/2006/main">
             <a:pPr>
+              <a:buNone/>
               <a:defRPr sz="3675" b="1">
                 <a:solidFill>
                   <a:srgbClr val="FFFFFF"/>
@@ -5687,6 +6286,7 @@
           </a:lstStyle>
           <a:p xmlns:a="http://schemas.openxmlformats.org/drawingml/2006/main">
             <a:pPr>
+              <a:buNone/>
               <a:defRPr sz="2100" b="0">
                 <a:solidFill>
                   <a:srgbClr val="DDE8F0"/>
@@ -5705,11 +6305,12 @@
                 <a:ea typeface="Arial"/>
                 <a:cs typeface="Arial"/>
               </a:rPr>
-              <a:t>Подключение $1 000. Подписка $300 в месяц.</a:t>
+              <a:t>На объект: подключение $1 000, подписка $300 в месяц.</a:t>
             </a:r>
           </a:p>
           <a:p xmlns:a="http://schemas.openxmlformats.org/drawingml/2006/main">
             <a:pPr>
+              <a:buNone/>
               <a:defRPr sz="2100" b="0">
                 <a:solidFill>
                   <a:srgbClr val="DDE8F0"/>
@@ -5728,7 +6329,7 @@
                 <a:ea typeface="Arial"/>
                 <a:cs typeface="Arial"/>
               </a:rPr>
-              <a:t>Прямые расходы $120 в месяц. Остаток до общих расходов $180.</a:t>
+              <a:t>Прямые расходы $120, вклад до общих расходов $180 в месяц.</a:t>
             </a:r>
           </a:p>
           <a:p xmlns:a="http://schemas.openxmlformats.org/drawingml/2006/main">
@@ -5738,6 +6339,7 @@
           </a:p>
           <a:p xmlns:a="http://schemas.openxmlformats.org/drawingml/2006/main">
             <a:pPr>
+              <a:buNone/>
               <a:defRPr sz="2100" b="0">
                 <a:solidFill>
                   <a:srgbClr val="DDE8F0"/>
@@ -5756,11 +6358,12 @@
                 <a:ea typeface="Arial"/>
                 <a:cs typeface="Arial"/>
               </a:rPr>
-              <a:t>При выгоде клиента $600 в месяц: после подписки остаётся $300.</a:t>
+              <a:t>Для окупаемости за 6 месяцев клиенту нужна подтверждённая</a:t>
             </a:r>
           </a:p>
           <a:p xmlns:a="http://schemas.openxmlformats.org/drawingml/2006/main">
             <a:pPr>
+              <a:buNone/>
               <a:defRPr sz="2100" b="0">
                 <a:solidFill>
                   <a:srgbClr val="DDE8F0"/>
@@ -5779,7 +6382,7 @@
                 <a:ea typeface="Arial"/>
                 <a:cs typeface="Arial"/>
               </a:rPr>
-              <a:t>Окупаемость подключения: 3,3 месяца.</a:t>
+              <a:t>экономия не менее $467 в месяц до подписки.</a:t>
             </a:r>
           </a:p>
           <a:p xmlns:a="http://schemas.openxmlformats.org/drawingml/2006/main">
@@ -5789,6 +6392,7 @@
           </a:p>
           <a:p xmlns:a="http://schemas.openxmlformats.org/drawingml/2006/main">
             <a:pPr>
+              <a:buNone/>
               <a:defRPr sz="2100" b="0">
                 <a:solidFill>
                   <a:srgbClr val="DDE8F0"/>
@@ -5807,7 +6411,31 @@
                 <a:ea typeface="Arial"/>
                 <a:cs typeface="Arial"/>
               </a:rPr>
-              <a:t>Выгода не измерена. Оборудование и городская интеграция отдельно.</a:t>
+              <a:t>Все цены и расходы являются гипотезами. Продаж пока нет.</a:t>
+            </a:r>
+          </a:p>
+          <a:p xmlns:a="http://schemas.openxmlformats.org/drawingml/2006/main">
+            <a:pPr>
+              <a:buNone/>
+              <a:defRPr sz="2100" b="0">
+                <a:solidFill>
+                  <a:srgbClr val="DDE8F0"/>
+                </a:solidFill>
+                <a:latin typeface="Arial"/>
+                <a:ea typeface="Arial"/>
+                <a:cs typeface="Arial"/>
+              </a:defRPr>
+            </a:pPr>
+            <a:r>
+              <a:rPr sz="2100" b="0">
+                <a:solidFill>
+                  <a:srgbClr val="DDE8F0"/>
+                </a:solidFill>
+                <a:latin typeface="Arial"/>
+                <a:ea typeface="Arial"/>
+                <a:cs typeface="Arial"/>
+              </a:rPr>
+              <a:t>Оборудование, монтаж и городская интеграция считаются отдельно.</a:t>
             </a:r>
           </a:p>
         </p:txBody>
@@ -5855,6 +6483,7 @@
           </a:lstStyle>
           <a:p xmlns:a="http://schemas.openxmlformats.org/drawingml/2006/main">
             <a:pPr>
+              <a:buNone/>
               <a:defRPr sz="1050" b="0">
                 <a:solidFill>
                   <a:srgbClr val="8C9BAA"/>
@@ -5950,6 +6579,7 @@
           </a:lstStyle>
           <a:p xmlns:a="http://schemas.openxmlformats.org/drawingml/2006/main">
             <a:pPr>
+              <a:buNone/>
               <a:defRPr sz="1200" b="1">
                 <a:solidFill>
                   <a:srgbClr val="70E4B7"/>
@@ -6016,6 +6646,7 @@
           </a:lstStyle>
           <a:p xmlns:a="http://schemas.openxmlformats.org/drawingml/2006/main">
             <a:pPr>
+              <a:buNone/>
               <a:defRPr sz="3675" b="1">
                 <a:solidFill>
                   <a:srgbClr val="FFFFFF"/>
@@ -6034,7 +6665,7 @@
                 <a:ea typeface="Arial"/>
                 <a:cs typeface="Arial"/>
               </a:rPr>
-              <a:t>Следующий шаг: измеряемый пилот</a:t>
+              <a:t>Пилот с измеримыми условиями</a:t>
             </a:r>
           </a:p>
         </p:txBody>
@@ -6082,6 +6713,7 @@
           </a:lstStyle>
           <a:p xmlns:a="http://schemas.openxmlformats.org/drawingml/2006/main">
             <a:pPr>
+              <a:buNone/>
               <a:defRPr sz="2100" b="0">
                 <a:solidFill>
                   <a:srgbClr val="DDE8F0"/>
@@ -6100,11 +6732,12 @@
                 <a:ea typeface="Arial"/>
                 <a:cs typeface="Arial"/>
               </a:rPr>
-              <a:t>Проверить подсчёт на размеченных разрешённых видео.</a:t>
+              <a:t>Один оператор, 2 недели, 12 размеченных отрезков с разных камер.</a:t>
             </a:r>
           </a:p>
           <a:p xmlns:a="http://schemas.openxmlformats.org/drawingml/2006/main">
             <a:pPr>
+              <a:buNone/>
               <a:defRPr sz="2100" b="0">
                 <a:solidFill>
                   <a:srgbClr val="DDE8F0"/>
@@ -6123,11 +6756,12 @@
                 <a:ea typeface="Arial"/>
                 <a:cs typeface="Arial"/>
               </a:rPr>
-              <a:t>Откалибровать выбранные камеры и геометрию дорог.</a:t>
+              <a:t>Два независимых разметчика и отложенная проверка качества.</a:t>
             </a:r>
           </a:p>
           <a:p xmlns:a="http://schemas.openxmlformats.org/drawingml/2006/main">
             <a:pPr>
+              <a:buNone/>
               <a:defRPr sz="2100" b="0">
                 <a:solidFill>
                   <a:srgbClr val="DDE8F0"/>
@@ -6146,16 +6780,41 @@
                 <a:ea typeface="Arial"/>
                 <a:cs typeface="Arial"/>
               </a:rPr>
-              <a:t>Сопоставить прогноз очередей с фактическими наблюдениями.</a:t>
-            </a:r>
-          </a:p>
-          <a:p xmlns:a="http://schemas.openxmlformats.org/drawingml/2006/main">
-            <a:r>
+              <a:t>Цели: ошибка счёта ≤10%, precision и recall событий ≥0,90.</a:t>
+            </a:r>
+          </a:p>
+          <a:p xmlns:a="http://schemas.openxmlformats.org/drawingml/2006/main">
+            <a:r>
+              <a:t>Порог ошибки прогноза очереди согласуется до испытаний.</a:t>
+            </a:r>
+          </a:p>
+          <a:p xmlns:a="http://schemas.openxmlformats.org/drawingml/2006/main">
+            <a:pPr>
+              <a:buNone/>
+              <a:defRPr sz="2100" b="0">
+                <a:solidFill>
+                  <a:srgbClr val="DDE8F0"/>
+                </a:solidFill>
+                <a:latin typeface="Arial"/>
+                <a:ea typeface="Arial"/>
+                <a:cs typeface="Arial"/>
+              </a:defRPr>
+            </a:pPr>
+            <a:r>
+              <a:rPr sz="2100" b="0">
+                <a:solidFill>
+                  <a:srgbClr val="DDE8F0"/>
+                </a:solidFill>
+                <a:latin typeface="Arial"/>
+                <a:ea typeface="Arial"/>
+                <a:cs typeface="Arial"/>
+              </a:rPr>
               <a:t/>
             </a:r>
           </a:p>
           <a:p xmlns:a="http://schemas.openxmlformats.org/drawingml/2006/main">
             <a:pPr>
+              <a:buNone/>
               <a:defRPr sz="2100" b="0">
                 <a:solidFill>
                   <a:srgbClr val="DDE8F0"/>
@@ -6174,11 +6833,12 @@
                 <a:ea typeface="Arial"/>
                 <a:cs typeface="Arial"/>
               </a:rPr>
-              <a:t>Коммерческая защита: интеграции и накопленные проверенные данные.</a:t>
+              <a:t>Бизнес-защита в перспективе: проверенные данные и интеграции.</a:t>
             </a:r>
           </a:p>
           <a:p xmlns:a="http://schemas.openxmlformats.org/drawingml/2006/main">
             <a:pPr>
+              <a:buNone/>
               <a:defRPr sz="2100" b="0">
                 <a:solidFill>
                   <a:srgbClr val="DDE8F0"/>
@@ -6197,7 +6857,7 @@
                 <a:ea typeface="Arial"/>
                 <a:cs typeface="Arial"/>
               </a:rPr>
-              <a:t>Один открытый детектор сам по себе не создаёт барьер копирования.</a:t>
+              <a:t>Сегодня код открыт, преимущества внедрения ещё не доказаны.</a:t>
             </a:r>
           </a:p>
         </p:txBody>
@@ -6245,6 +6905,7 @@
           </a:lstStyle>
           <a:p xmlns:a="http://schemas.openxmlformats.org/drawingml/2006/main">
             <a:pPr>
+              <a:buNone/>
               <a:defRPr sz="1050" b="0">
                 <a:solidFill>
                   <a:srgbClr val="8C9BAA"/>

</xml_diff>